<commit_message>
Make QCC PPT templates data-editable
Add data-entry slides, editable sample tables, and a Pareto chart data surface so users can adapt templates primarily by replacing data. Refresh PPTX asset tests and validation evidence.
</commit_message>
<xml_diff>
--- a/templates/ppt/methods/5-whys-template.pptx
+++ b/templates/ppt/methods/5-whys-template.pptx
@@ -8,6 +8,7 @@
     <p:sldId id="256" r:id="rId7"/>
     <p:sldId id="257" r:id="rId8"/>
     <p:sldId id="258" r:id="rId9"/>
+    <p:sldId id="259" r:id="rId10"/>
   </p:sldIdLst>
   <p:sldSz cx="12191999" cy="6858000" type="screen4x3"/>
   <p:notesSz cx="6858000" cy="9144000"/>
@@ -3592,6 +3593,844 @@
                   <a:srgbClr val="1B2733"/>
                 </a:solidFill>
               </a:rPr>
+              <a:t>DATA ENTRY - replace why-chain answers only</a:t>
+            </a:r>
+          </a:p>
+        </p:txBody>
+      </p:sp>
+      <p:sp>
+        <p:nvSpPr>
+          <p:cNvPr id="3" name="TextBox 2"/>
+          <p:cNvSpPr txBox="1"/>
+          <p:nvPr/>
+        </p:nvSpPr>
+        <p:spPr>
+          <a:xfrm>
+            <a:off x="521207" y="713232"/>
+            <a:ext cx="7772400" cy="237744"/>
+          </a:xfrm>
+          <a:prstGeom prst="rect">
+            <a:avLst/>
+          </a:prstGeom>
+          <a:noFill/>
+        </p:spPr>
+        <p:txBody>
+          <a:bodyPr wrap="square" lIns="73152" rIns="73152">
+            <a:spAutoFit/>
+          </a:bodyPr>
+          <a:lstStyle/>
+          <a:p>
+            <a:r>
+              <a:rPr sz="1100" b="0">
+                <a:solidFill>
+                  <a:srgbClr val="5A636C"/>
+                </a:solidFill>
+              </a:rPr>
+              <a:t>5 Whys</a:t>
+            </a:r>
+          </a:p>
+        </p:txBody>
+      </p:sp>
+      <p:sp>
+        <p:nvSpPr>
+          <p:cNvPr id="4" name="Rectangle 3"/>
+          <p:cNvSpPr/>
+          <p:nvPr/>
+        </p:nvSpPr>
+        <p:spPr>
+          <a:xfrm>
+            <a:off x="502920" y="941832"/>
+            <a:ext cx="11155680" cy="27432"/>
+          </a:xfrm>
+          <a:prstGeom prst="rect">
+            <a:avLst/>
+          </a:prstGeom>
+          <a:solidFill>
+            <a:srgbClr val="427E78"/>
+          </a:solidFill>
+          <a:ln>
+            <a:noFill/>
+          </a:ln>
+        </p:spPr>
+        <p:style>
+          <a:lnRef idx="1">
+            <a:schemeClr val="accent1"/>
+          </a:lnRef>
+          <a:fillRef idx="3">
+            <a:schemeClr val="accent1"/>
+          </a:fillRef>
+          <a:effectRef idx="2">
+            <a:schemeClr val="accent1"/>
+          </a:effectRef>
+          <a:fontRef idx="minor">
+            <a:schemeClr val="lt1"/>
+          </a:fontRef>
+        </p:style>
+        <p:txBody>
+          <a:bodyPr rtlCol="0" anchor="ctr"/>
+          <a:lstStyle/>
+          <a:p>
+            <a:pPr algn="ctr"/>
+          </a:p>
+        </p:txBody>
+      </p:sp>
+      <p:sp>
+        <p:nvSpPr>
+          <p:cNvPr id="5" name="Rounded Rectangle 4"/>
+          <p:cNvSpPr/>
+          <p:nvPr/>
+        </p:nvSpPr>
+        <p:spPr>
+          <a:xfrm>
+            <a:off x="640080" y="1051560"/>
+            <a:ext cx="4572000" cy="329184"/>
+          </a:xfrm>
+          <a:prstGeom prst="roundRect">
+            <a:avLst/>
+          </a:prstGeom>
+          <a:solidFill>
+            <a:srgbClr val="FFF2CC"/>
+          </a:solidFill>
+          <a:ln>
+            <a:solidFill>
+              <a:srgbClr val="D69F2E"/>
+            </a:solidFill>
+          </a:ln>
+        </p:spPr>
+        <p:style>
+          <a:lnRef idx="1">
+            <a:schemeClr val="accent1"/>
+          </a:lnRef>
+          <a:fillRef idx="3">
+            <a:schemeClr val="accent1"/>
+          </a:fillRef>
+          <a:effectRef idx="2">
+            <a:schemeClr val="accent1"/>
+          </a:effectRef>
+          <a:fontRef idx="minor">
+            <a:schemeClr val="lt1"/>
+          </a:fontRef>
+        </p:style>
+        <p:txBody>
+          <a:bodyPr rtlCol="0" anchor="ctr"/>
+          <a:lstStyle/>
+          <a:p>
+            <a:pPr algn="ctr"/>
+            <a:r>
+              <a:rPr b="1" sz="1100">
+                <a:solidFill>
+                  <a:srgbClr val="664B11"/>
+                </a:solidFill>
+              </a:rPr>
+              <a:t>Change data only - keep layout and labels</a:t>
+            </a:r>
+          </a:p>
+        </p:txBody>
+      </p:sp>
+      <p:graphicFrame>
+        <p:nvGraphicFramePr>
+          <p:cNvPr id="6" name="Table 5"/>
+          <p:cNvGraphicFramePr>
+            <a:graphicFrameLocks noGrp="1"/>
+          </p:cNvGraphicFramePr>
+          <p:nvPr/>
+        </p:nvGraphicFramePr>
+        <p:xfrm>
+          <a:off x="640080" y="1645920"/>
+          <a:ext cx="5486400" cy="4343400"/>
+        </p:xfrm>
+        <a:graphic>
+          <a:graphicData uri="http://schemas.openxmlformats.org/drawingml/2006/table">
+            <a:tbl>
+              <a:tblPr firstRow="1" bandRow="1">
+                <a:tableStyleId>{5C22544A-7EE6-4342-B048-85BDC9FD1C3A}</a:tableStyleId>
+              </a:tblPr>
+              <a:tblGrid>
+                <a:gridCol w="1828800"/>
+                <a:gridCol w="1828800"/>
+                <a:gridCol w="1828800"/>
+              </a:tblGrid>
+              <a:tr h="620485">
+                <a:tc>
+                  <a:txBody>
+                    <a:bodyPr/>
+                    <a:lstStyle/>
+                    <a:p>
+                      <a:pPr>
+                        <a:defRPr sz="800">
+                          <a:solidFill>
+                            <a:srgbClr val="FFFFFF"/>
+                          </a:solidFill>
+                        </a:defRPr>
+                      </a:pPr>
+                      <a:r>
+                        <a:t>Step</a:t>
+                      </a:r>
+                    </a:p>
+                  </a:txBody>
+                  <a:tcPr marL="45720" marR="45720" marT="27432" marB="27432">
+                    <a:solidFill>
+                      <a:srgbClr val="427E78"/>
+                    </a:solidFill>
+                  </a:tcPr>
+                </a:tc>
+                <a:tc>
+                  <a:txBody>
+                    <a:bodyPr/>
+                    <a:lstStyle/>
+                    <a:p>
+                      <a:pPr>
+                        <a:defRPr sz="800">
+                          <a:solidFill>
+                            <a:srgbClr val="FFFFFF"/>
+                          </a:solidFill>
+                        </a:defRPr>
+                      </a:pPr>
+                      <a:r>
+                        <a:t>Why answer</a:t>
+                      </a:r>
+                    </a:p>
+                  </a:txBody>
+                  <a:tcPr marL="45720" marR="45720" marT="27432" marB="27432">
+                    <a:solidFill>
+                      <a:srgbClr val="427E78"/>
+                    </a:solidFill>
+                  </a:tcPr>
+                </a:tc>
+                <a:tc>
+                  <a:txBody>
+                    <a:bodyPr/>
+                    <a:lstStyle/>
+                    <a:p>
+                      <a:pPr>
+                        <a:defRPr sz="800">
+                          <a:solidFill>
+                            <a:srgbClr val="FFFFFF"/>
+                          </a:solidFill>
+                        </a:defRPr>
+                      </a:pPr>
+                      <a:r>
+                        <a:t>Evidence check</a:t>
+                      </a:r>
+                    </a:p>
+                  </a:txBody>
+                  <a:tcPr marL="45720" marR="45720" marT="27432" marB="27432">
+                    <a:solidFill>
+                      <a:srgbClr val="427E78"/>
+                    </a:solidFill>
+                  </a:tcPr>
+                </a:tc>
+              </a:tr>
+              <a:tr h="620485">
+                <a:tc>
+                  <a:txBody>
+                    <a:bodyPr/>
+                    <a:lstStyle/>
+                    <a:p>
+                      <a:pPr>
+                        <a:defRPr sz="800">
+                          <a:solidFill>
+                            <a:srgbClr val="232D37"/>
+                          </a:solidFill>
+                        </a:defRPr>
+                      </a:pPr>
+                      <a:r>
+                        <a:t>Problem</a:t>
+                      </a:r>
+                    </a:p>
+                  </a:txBody>
+                  <a:tcPr marL="45720" marR="45720" marT="27432" marB="27432">
+                    <a:solidFill>
+                      <a:srgbClr val="F8F9F7"/>
+                    </a:solidFill>
+                  </a:tcPr>
+                </a:tc>
+                <a:tc>
+                  <a:txBody>
+                    <a:bodyPr/>
+                    <a:lstStyle/>
+                    <a:p>
+                      <a:pPr>
+                        <a:defRPr sz="800">
+                          <a:solidFill>
+                            <a:srgbClr val="232D37"/>
+                          </a:solidFill>
+                        </a:defRPr>
+                      </a:pPr>
+                      <a:r>
+                        <a:t>Wrong label applied to packed cartons</a:t>
+                      </a:r>
+                    </a:p>
+                  </a:txBody>
+                  <a:tcPr marL="45720" marR="45720" marT="27432" marB="27432">
+                    <a:solidFill>
+                      <a:srgbClr val="F8F9F7"/>
+                    </a:solidFill>
+                  </a:tcPr>
+                </a:tc>
+                <a:tc>
+                  <a:txBody>
+                    <a:bodyPr/>
+                    <a:lstStyle/>
+                    <a:p>
+                      <a:pPr>
+                        <a:defRPr sz="800">
+                          <a:solidFill>
+                            <a:srgbClr val="232D37"/>
+                          </a:solidFill>
+                        </a:defRPr>
+                      </a:pPr>
+                      <a:r>
+                        <a:t>Pareto category</a:t>
+                      </a:r>
+                    </a:p>
+                  </a:txBody>
+                  <a:tcPr marL="45720" marR="45720" marT="27432" marB="27432">
+                    <a:solidFill>
+                      <a:srgbClr val="F8F9F7"/>
+                    </a:solidFill>
+                  </a:tcPr>
+                </a:tc>
+              </a:tr>
+              <a:tr h="620485">
+                <a:tc>
+                  <a:txBody>
+                    <a:bodyPr/>
+                    <a:lstStyle/>
+                    <a:p>
+                      <a:pPr>
+                        <a:defRPr sz="800">
+                          <a:solidFill>
+                            <a:srgbClr val="232D37"/>
+                          </a:solidFill>
+                        </a:defRPr>
+                      </a:pPr>
+                      <a:r>
+                        <a:t>Why 1</a:t>
+                      </a:r>
+                    </a:p>
+                  </a:txBody>
+                  <a:tcPr marL="45720" marR="45720" marT="27432" marB="27432">
+                    <a:solidFill>
+                      <a:srgbClr val="EEF4F3"/>
+                    </a:solidFill>
+                  </a:tcPr>
+                </a:tc>
+                <a:tc>
+                  <a:txBody>
+                    <a:bodyPr/>
+                    <a:lstStyle/>
+                    <a:p>
+                      <a:pPr>
+                        <a:defRPr sz="800">
+                          <a:solidFill>
+                            <a:srgbClr val="232D37"/>
+                          </a:solidFill>
+                        </a:defRPr>
+                      </a:pPr>
+                      <a:r>
+                        <a:t>Operator selected wrong label roll</a:t>
+                      </a:r>
+                    </a:p>
+                  </a:txBody>
+                  <a:tcPr marL="45720" marR="45720" marT="27432" marB="27432">
+                    <a:solidFill>
+                      <a:srgbClr val="EEF4F3"/>
+                    </a:solidFill>
+                  </a:tcPr>
+                </a:tc>
+                <a:tc>
+                  <a:txBody>
+                    <a:bodyPr/>
+                    <a:lstStyle/>
+                    <a:p>
+                      <a:pPr>
+                        <a:defRPr sz="800">
+                          <a:solidFill>
+                            <a:srgbClr val="232D37"/>
+                          </a:solidFill>
+                        </a:defRPr>
+                      </a:pPr>
+                      <a:r>
+                        <a:t>Observed case review</a:t>
+                      </a:r>
+                    </a:p>
+                  </a:txBody>
+                  <a:tcPr marL="45720" marR="45720" marT="27432" marB="27432">
+                    <a:solidFill>
+                      <a:srgbClr val="EEF4F3"/>
+                    </a:solidFill>
+                  </a:tcPr>
+                </a:tc>
+              </a:tr>
+              <a:tr h="620485">
+                <a:tc>
+                  <a:txBody>
+                    <a:bodyPr/>
+                    <a:lstStyle/>
+                    <a:p>
+                      <a:pPr>
+                        <a:defRPr sz="800">
+                          <a:solidFill>
+                            <a:srgbClr val="232D37"/>
+                          </a:solidFill>
+                        </a:defRPr>
+                      </a:pPr>
+                      <a:r>
+                        <a:t>Why 2</a:t>
+                      </a:r>
+                    </a:p>
+                  </a:txBody>
+                  <a:tcPr marL="45720" marR="45720" marT="27432" marB="27432">
+                    <a:solidFill>
+                      <a:srgbClr val="F8F9F7"/>
+                    </a:solidFill>
+                  </a:tcPr>
+                </a:tc>
+                <a:tc>
+                  <a:txBody>
+                    <a:bodyPr/>
+                    <a:lstStyle/>
+                    <a:p>
+                      <a:pPr>
+                        <a:defRPr sz="800">
+                          <a:solidFill>
+                            <a:srgbClr val="232D37"/>
+                          </a:solidFill>
+                        </a:defRPr>
+                      </a:pPr>
+                      <a:r>
+                        <a:t>Similar rolls stored together</a:t>
+                      </a:r>
+                    </a:p>
+                  </a:txBody>
+                  <a:tcPr marL="45720" marR="45720" marT="27432" marB="27432">
+                    <a:solidFill>
+                      <a:srgbClr val="F8F9F7"/>
+                    </a:solidFill>
+                  </a:tcPr>
+                </a:tc>
+                <a:tc>
+                  <a:txBody>
+                    <a:bodyPr/>
+                    <a:lstStyle/>
+                    <a:p>
+                      <a:pPr>
+                        <a:defRPr sz="800">
+                          <a:solidFill>
+                            <a:srgbClr val="232D37"/>
+                          </a:solidFill>
+                        </a:defRPr>
+                      </a:pPr>
+                      <a:r>
+                        <a:t>Storage check</a:t>
+                      </a:r>
+                    </a:p>
+                  </a:txBody>
+                  <a:tcPr marL="45720" marR="45720" marT="27432" marB="27432">
+                    <a:solidFill>
+                      <a:srgbClr val="F8F9F7"/>
+                    </a:solidFill>
+                  </a:tcPr>
+                </a:tc>
+              </a:tr>
+              <a:tr h="620485">
+                <a:tc>
+                  <a:txBody>
+                    <a:bodyPr/>
+                    <a:lstStyle/>
+                    <a:p>
+                      <a:pPr>
+                        <a:defRPr sz="800">
+                          <a:solidFill>
+                            <a:srgbClr val="232D37"/>
+                          </a:solidFill>
+                        </a:defRPr>
+                      </a:pPr>
+                      <a:r>
+                        <a:t>Why 3</a:t>
+                      </a:r>
+                    </a:p>
+                  </a:txBody>
+                  <a:tcPr marL="45720" marR="45720" marT="27432" marB="27432">
+                    <a:solidFill>
+                      <a:srgbClr val="EEF4F3"/>
+                    </a:solidFill>
+                  </a:tcPr>
+                </a:tc>
+                <a:tc>
+                  <a:txBody>
+                    <a:bodyPr/>
+                    <a:lstStyle/>
+                    <a:p>
+                      <a:pPr>
+                        <a:defRPr sz="800">
+                          <a:solidFill>
+                            <a:srgbClr val="232D37"/>
+                          </a:solidFill>
+                        </a:defRPr>
+                      </a:pPr>
+                      <a:r>
+                        <a:t>No visual separation standard</a:t>
+                      </a:r>
+                    </a:p>
+                  </a:txBody>
+                  <a:tcPr marL="45720" marR="45720" marT="27432" marB="27432">
+                    <a:solidFill>
+                      <a:srgbClr val="EEF4F3"/>
+                    </a:solidFill>
+                  </a:tcPr>
+                </a:tc>
+                <a:tc>
+                  <a:txBody>
+                    <a:bodyPr/>
+                    <a:lstStyle/>
+                    <a:p>
+                      <a:pPr>
+                        <a:defRPr sz="800">
+                          <a:solidFill>
+                            <a:srgbClr val="232D37"/>
+                          </a:solidFill>
+                        </a:defRPr>
+                      </a:pPr>
+                      <a:r>
+                        <a:t>SOP review</a:t>
+                      </a:r>
+                    </a:p>
+                  </a:txBody>
+                  <a:tcPr marL="45720" marR="45720" marT="27432" marB="27432">
+                    <a:solidFill>
+                      <a:srgbClr val="EEF4F3"/>
+                    </a:solidFill>
+                  </a:tcPr>
+                </a:tc>
+              </a:tr>
+              <a:tr h="620485">
+                <a:tc>
+                  <a:txBody>
+                    <a:bodyPr/>
+                    <a:lstStyle/>
+                    <a:p>
+                      <a:pPr>
+                        <a:defRPr sz="800">
+                          <a:solidFill>
+                            <a:srgbClr val="232D37"/>
+                          </a:solidFill>
+                        </a:defRPr>
+                      </a:pPr>
+                      <a:r>
+                        <a:t>Why 4</a:t>
+                      </a:r>
+                    </a:p>
+                  </a:txBody>
+                  <a:tcPr marL="45720" marR="45720" marT="27432" marB="27432">
+                    <a:solidFill>
+                      <a:srgbClr val="F8F9F7"/>
+                    </a:solidFill>
+                  </a:tcPr>
+                </a:tc>
+                <a:tc>
+                  <a:txBody>
+                    <a:bodyPr/>
+                    <a:lstStyle/>
+                    <a:p>
+                      <a:pPr>
+                        <a:defRPr sz="800">
+                          <a:solidFill>
+                            <a:srgbClr val="232D37"/>
+                          </a:solidFill>
+                        </a:defRPr>
+                      </a:pPr>
+                      <a:r>
+                        <a:t>Storage standard was never updated</a:t>
+                      </a:r>
+                    </a:p>
+                  </a:txBody>
+                  <a:tcPr marL="45720" marR="45720" marT="27432" marB="27432">
+                    <a:solidFill>
+                      <a:srgbClr val="F8F9F7"/>
+                    </a:solidFill>
+                  </a:tcPr>
+                </a:tc>
+                <a:tc>
+                  <a:txBody>
+                    <a:bodyPr/>
+                    <a:lstStyle/>
+                    <a:p>
+                      <a:pPr>
+                        <a:defRPr sz="800">
+                          <a:solidFill>
+                            <a:srgbClr val="232D37"/>
+                          </a:solidFill>
+                        </a:defRPr>
+                      </a:pPr>
+                      <a:r>
+                        <a:t>Owner interview</a:t>
+                      </a:r>
+                    </a:p>
+                  </a:txBody>
+                  <a:tcPr marL="45720" marR="45720" marT="27432" marB="27432">
+                    <a:solidFill>
+                      <a:srgbClr val="F8F9F7"/>
+                    </a:solidFill>
+                  </a:tcPr>
+                </a:tc>
+              </a:tr>
+              <a:tr h="620490">
+                <a:tc>
+                  <a:txBody>
+                    <a:bodyPr/>
+                    <a:lstStyle/>
+                    <a:p>
+                      <a:pPr>
+                        <a:defRPr sz="800">
+                          <a:solidFill>
+                            <a:srgbClr val="232D37"/>
+                          </a:solidFill>
+                        </a:defRPr>
+                      </a:pPr>
+                      <a:r>
+                        <a:t>Why 5</a:t>
+                      </a:r>
+                    </a:p>
+                  </a:txBody>
+                  <a:tcPr marL="45720" marR="45720" marT="27432" marB="27432">
+                    <a:solidFill>
+                      <a:srgbClr val="EEF4F3"/>
+                    </a:solidFill>
+                  </a:tcPr>
+                </a:tc>
+                <a:tc>
+                  <a:txBody>
+                    <a:bodyPr/>
+                    <a:lstStyle/>
+                    <a:p>
+                      <a:pPr>
+                        <a:defRPr sz="800">
+                          <a:solidFill>
+                            <a:srgbClr val="232D37"/>
+                          </a:solidFill>
+                        </a:defRPr>
+                      </a:pPr>
+                      <a:r>
+                        <a:t>Change-control step missing</a:t>
+                      </a:r>
+                    </a:p>
+                  </a:txBody>
+                  <a:tcPr marL="45720" marR="45720" marT="27432" marB="27432">
+                    <a:solidFill>
+                      <a:srgbClr val="EEF4F3"/>
+                    </a:solidFill>
+                  </a:tcPr>
+                </a:tc>
+                <a:tc>
+                  <a:txBody>
+                    <a:bodyPr/>
+                    <a:lstStyle/>
+                    <a:p>
+                      <a:pPr>
+                        <a:defRPr sz="800">
+                          <a:solidFill>
+                            <a:srgbClr val="232D37"/>
+                          </a:solidFill>
+                        </a:defRPr>
+                      </a:pPr>
+                      <a:r>
+                        <a:t>Procedure audit</a:t>
+                      </a:r>
+                    </a:p>
+                  </a:txBody>
+                  <a:tcPr marL="45720" marR="45720" marT="27432" marB="27432">
+                    <a:solidFill>
+                      <a:srgbClr val="EEF4F3"/>
+                    </a:solidFill>
+                  </a:tcPr>
+                </a:tc>
+              </a:tr>
+            </a:tbl>
+          </a:graphicData>
+        </a:graphic>
+      </p:graphicFrame>
+      <p:sp>
+        <p:nvSpPr>
+          <p:cNvPr id="7" name="Rounded Rectangle 6"/>
+          <p:cNvSpPr/>
+          <p:nvPr/>
+        </p:nvSpPr>
+        <p:spPr>
+          <a:xfrm>
+            <a:off x="6400800" y="1645920"/>
+            <a:ext cx="4937760" cy="4343400"/>
+          </a:xfrm>
+          <a:prstGeom prst="roundRect">
+            <a:avLst/>
+          </a:prstGeom>
+          <a:solidFill>
+            <a:srgbClr val="F8F9F7"/>
+          </a:solidFill>
+          <a:ln>
+            <a:solidFill>
+              <a:srgbClr val="BEC4BF"/>
+            </a:solidFill>
+          </a:ln>
+        </p:spPr>
+        <p:style>
+          <a:lnRef idx="1">
+            <a:schemeClr val="accent1"/>
+          </a:lnRef>
+          <a:fillRef idx="3">
+            <a:schemeClr val="accent1"/>
+          </a:fillRef>
+          <a:effectRef idx="2">
+            <a:schemeClr val="accent1"/>
+          </a:effectRef>
+          <a:fontRef idx="minor">
+            <a:schemeClr val="lt1"/>
+          </a:fontRef>
+        </p:style>
+        <p:txBody>
+          <a:bodyPr rtlCol="0" anchor="t" lIns="164592" rIns="164592" tIns="128016"/>
+          <a:lstStyle/>
+          <a:p>
+            <a:pPr algn="ctr"/>
+            <a:r>
+              <a:rPr b="1" sz="1500">
+                <a:solidFill>
+                  <a:srgbClr val="1B2733"/>
+                </a:solidFill>
+              </a:rPr>
+              <a:t>How to use this template</a:t>
+            </a:r>
+          </a:p>
+          <a:p>
+            <a:pPr>
+              <a:defRPr sz="1100">
+                <a:solidFill>
+                  <a:srgbClr val="2D3741"/>
+                </a:solidFill>
+              </a:defRPr>
+            </a:pPr>
+            <a:r>
+              <a:t>Replace the sample rows with project data.</a:t>
+            </a:r>
+          </a:p>
+          <a:p>
+            <a:pPr>
+              <a:defRPr sz="1100">
+                <a:solidFill>
+                  <a:srgbClr val="2D3741"/>
+                </a:solidFill>
+              </a:defRPr>
+            </a:pPr>
+            <a:r>
+              <a:t>Keep the method labels and review fields.</a:t>
+            </a:r>
+          </a:p>
+          <a:p>
+            <a:pPr>
+              <a:defRPr sz="1100">
+                <a:solidFill>
+                  <a:srgbClr val="2D3741"/>
+                </a:solidFill>
+              </a:defRPr>
+            </a:pPr>
+            <a:r>
+              <a:t>Move the summarized result into the project slide.</a:t>
+            </a:r>
+          </a:p>
+          <a:p>
+            <a:pPr>
+              <a:defRPr sz="1100">
+                <a:solidFill>
+                  <a:srgbClr val="2D3741"/>
+                </a:solidFill>
+              </a:defRPr>
+            </a:pPr>
+            <a:r>
+              <a:t>Preserve evidence notes for review.</a:t>
+            </a:r>
+          </a:p>
+        </p:txBody>
+      </p:sp>
+      <p:sp>
+        <p:nvSpPr>
+          <p:cNvPr id="8" name="TextBox 7"/>
+          <p:cNvSpPr txBox="1"/>
+          <p:nvPr/>
+        </p:nvSpPr>
+        <p:spPr>
+          <a:xfrm>
+            <a:off x="548640" y="6355080"/>
+            <a:ext cx="10881360" cy="228600"/>
+          </a:xfrm>
+          <a:prstGeom prst="rect">
+            <a:avLst/>
+          </a:prstGeom>
+          <a:noFill/>
+        </p:spPr>
+        <p:txBody>
+          <a:bodyPr wrap="square" lIns="73152" rIns="73152">
+            <a:spAutoFit/>
+          </a:bodyPr>
+          <a:lstStyle/>
+          <a:p>
+            <a:r>
+              <a:rPr sz="800" b="0">
+                <a:solidFill>
+                  <a:srgbClr val="697077"/>
+                </a:solidFill>
+              </a:rPr>
+              <a:t>5_whys_method_template | 5_whys | Final data-dependent evidence belongs in the evidence package.</a:t>
+            </a:r>
+          </a:p>
+        </p:txBody>
+      </p:sp>
+    </p:spTree>
+  </p:cSld>
+  <p:clrMapOvr>
+    <a:masterClrMapping/>
+  </p:clrMapOvr>
+</p:sld>
+</file>
+
+<file path=ppt/slides/slide3.xml><?xml version="1.0" encoding="utf-8"?>
+<p:sld xmlns:a="http://schemas.openxmlformats.org/drawingml/2006/main" xmlns:p="http://schemas.openxmlformats.org/presentationml/2006/main" xmlns:r="http://schemas.openxmlformats.org/officeDocument/2006/relationships">
+  <p:cSld>
+    <p:spTree>
+      <p:nvGrpSpPr>
+        <p:cNvPr id="1" name=""/>
+        <p:cNvGrpSpPr/>
+        <p:nvPr/>
+      </p:nvGrpSpPr>
+      <p:grpSpPr/>
+      <p:sp>
+        <p:nvSpPr>
+          <p:cNvPr id="2" name="TextBox 1"/>
+          <p:cNvSpPr txBox="1"/>
+          <p:nvPr/>
+        </p:nvSpPr>
+        <p:spPr>
+          <a:xfrm>
+            <a:off x="502920" y="256032"/>
+            <a:ext cx="8321040" cy="420624"/>
+          </a:xfrm>
+          <a:prstGeom prst="rect">
+            <a:avLst/>
+          </a:prstGeom>
+          <a:noFill/>
+        </p:spPr>
+        <p:txBody>
+          <a:bodyPr wrap="square" lIns="73152" rIns="73152">
+            <a:spAutoFit/>
+          </a:bodyPr>
+          <a:lstStyle/>
+          <a:p>
+            <a:r>
+              <a:rPr sz="2400" b="1">
+                <a:solidFill>
+                  <a:srgbClr val="1B2733"/>
+                </a:solidFill>
+              </a:rPr>
               <a:t>DEMO EXAMPLE - not project evidence</a:t>
             </a:r>
           </a:p>
@@ -3786,6 +4625,18 @@
               </a:defRPr>
             </a:pPr>
             <a:r>
+              <a:t>Change data only: replace the why-chain answers and evidence checks.</a:t>
+            </a:r>
+          </a:p>
+          <a:p>
+            <a:pPr>
+              <a:defRPr sz="1100">
+                <a:solidFill>
+                  <a:srgbClr val="2D3741"/>
+                </a:solidFill>
+              </a:defRPr>
+            </a:pPr>
+            <a:r>
               <a:t>Problem: {{problem}}</a:t>
             </a:r>
           </a:p>
@@ -4005,7 +4856,7 @@
 </p:sld>
 </file>
 
-<file path=ppt/slides/slide3.xml><?xml version="1.0" encoding="utf-8"?>
+<file path=ppt/slides/slide4.xml><?xml version="1.0" encoding="utf-8"?>
 <p:sld xmlns:a="http://schemas.openxmlformats.org/drawingml/2006/main" xmlns:p="http://schemas.openxmlformats.org/presentationml/2006/main" xmlns:r="http://schemas.openxmlformats.org/officeDocument/2006/relationships">
   <p:cSld>
     <p:spTree>
@@ -4237,19 +5088,7 @@
               </a:defRPr>
             </a:pPr>
             <a:r>
-              <a:t>Start with the specific problem in {{problem}}.</a:t>
-            </a:r>
-          </a:p>
-          <a:p>
-            <a:pPr>
-              <a:defRPr sz="1100">
-                <a:solidFill>
-                  <a:srgbClr val="2D3741"/>
-                </a:solidFill>
-              </a:defRPr>
-            </a:pPr>
-            <a:r>
-              <a:t>Build the cause chain in {{why_chain}}.</a:t>
+              <a:t>Replace the rows with project why answers.</a:t>
             </a:r>
           </a:p>
           <a:p>

</xml_diff>

<commit_message>
M3: implement template-native method kits
Validation:

- .venv/bin/python -m pytest tests/test_method_guides.py tests/test_template_assets.py tests/test_template_catalog.py: 17 passed

- .venv/bin/python tools/build_ppt_templates.py: passed

- .venv/bin/python -m qcc_toolkit.templates validate templates/ppt/catalog.yml: validated 5 template catalog entries

- .venv/bin/python -m ruff check .: passed

- .venv/bin/python -m mypy qcc_toolkit: passed

- git diff --check: passed
</commit_message>
<xml_diff>
--- a/templates/ppt/methods/5-whys-template.pptx
+++ b/templates/ppt/methods/5-whys-template.pptx
@@ -9,6 +9,12 @@
     <p:sldId id="257" r:id="rId8"/>
     <p:sldId id="258" r:id="rId9"/>
     <p:sldId id="259" r:id="rId10"/>
+    <p:sldId id="260" r:id="rId11"/>
+    <p:sldId id="261" r:id="rId12"/>
+    <p:sldId id="262" r:id="rId13"/>
+    <p:sldId id="263" r:id="rId14"/>
+    <p:sldId id="264" r:id="rId15"/>
+    <p:sldId id="265" r:id="rId16"/>
   </p:sldIdLst>
   <p:sldSz cx="12191999" cy="6858000" type="screen4x3"/>
   <p:notesSz cx="6858000" cy="9144000"/>
@@ -3271,7 +3277,7 @@
                   <a:srgbClr val="232D37"/>
                 </a:solidFill>
               </a:rPr>
-              <a:t>Trace a problem through evidence-backed why links.</a:t>
+              <a:t>Purpose: trace a problem through evidence-backed why links.</a:t>
             </a:r>
           </a:p>
         </p:txBody>
@@ -3517,6 +3523,493 @@
       <p:sp>
         <p:nvSpPr>
           <p:cNvPr id="9" name="TextBox 8"/>
+          <p:cNvSpPr txBox="1"/>
+          <p:nvPr/>
+        </p:nvSpPr>
+        <p:spPr>
+          <a:xfrm>
+            <a:off x="548640" y="6355080"/>
+            <a:ext cx="10881360" cy="228600"/>
+          </a:xfrm>
+          <a:prstGeom prst="rect">
+            <a:avLst/>
+          </a:prstGeom>
+          <a:noFill/>
+        </p:spPr>
+        <p:txBody>
+          <a:bodyPr wrap="square" lIns="73152" rIns="73152">
+            <a:spAutoFit/>
+          </a:bodyPr>
+          <a:lstStyle/>
+          <a:p>
+            <a:r>
+              <a:rPr sz="800" b="0">
+                <a:solidFill>
+                  <a:srgbClr val="697077"/>
+                </a:solidFill>
+              </a:rPr>
+              <a:t>5_whys_method_template | 5_whys | Final data-dependent evidence belongs in the evidence package.</a:t>
+            </a:r>
+          </a:p>
+        </p:txBody>
+      </p:sp>
+    </p:spTree>
+  </p:cSld>
+  <p:clrMapOvr>
+    <a:masterClrMapping/>
+  </p:clrMapOvr>
+</p:sld>
+</file>
+
+<file path=ppt/slides/slide10.xml><?xml version="1.0" encoding="utf-8"?>
+<p:sld xmlns:a="http://schemas.openxmlformats.org/drawingml/2006/main" xmlns:p="http://schemas.openxmlformats.org/presentationml/2006/main" xmlns:r="http://schemas.openxmlformats.org/officeDocument/2006/relationships">
+  <p:cSld>
+    <p:spTree>
+      <p:nvGrpSpPr>
+        <p:cNvPr id="1" name=""/>
+        <p:cNvGrpSpPr/>
+        <p:nvPr/>
+      </p:nvGrpSpPr>
+      <p:grpSpPr/>
+      <p:sp>
+        <p:nvSpPr>
+          <p:cNvPr id="2" name="TextBox 1"/>
+          <p:cNvSpPr txBox="1"/>
+          <p:nvPr/>
+        </p:nvSpPr>
+        <p:spPr>
+          <a:xfrm>
+            <a:off x="502920" y="256032"/>
+            <a:ext cx="8321040" cy="420624"/>
+          </a:xfrm>
+          <a:prstGeom prst="rect">
+            <a:avLst/>
+          </a:prstGeom>
+          <a:noFill/>
+        </p:spPr>
+        <p:txBody>
+          <a:bodyPr wrap="square" lIns="73152" rIns="73152">
+            <a:spAutoFit/>
+          </a:bodyPr>
+          <a:lstStyle/>
+          <a:p>
+            <a:r>
+              <a:rPr sz="2400" b="1">
+                <a:solidFill>
+                  <a:srgbClr val="1B2733"/>
+                </a:solidFill>
+              </a:rPr>
+              <a:t>Blank working slide or worksheet</a:t>
+            </a:r>
+          </a:p>
+        </p:txBody>
+      </p:sp>
+      <p:sp>
+        <p:nvSpPr>
+          <p:cNvPr id="3" name="TextBox 2"/>
+          <p:cNvSpPr txBox="1"/>
+          <p:nvPr/>
+        </p:nvSpPr>
+        <p:spPr>
+          <a:xfrm>
+            <a:off x="521207" y="713232"/>
+            <a:ext cx="7772400" cy="237744"/>
+          </a:xfrm>
+          <a:prstGeom prst="rect">
+            <a:avLst/>
+          </a:prstGeom>
+          <a:noFill/>
+        </p:spPr>
+        <p:txBody>
+          <a:bodyPr wrap="square" lIns="73152" rIns="73152">
+            <a:spAutoFit/>
+          </a:bodyPr>
+          <a:lstStyle/>
+          <a:p>
+            <a:r>
+              <a:rPr sz="1100" b="0">
+                <a:solidFill>
+                  <a:srgbClr val="5A636C"/>
+                </a:solidFill>
+              </a:rPr>
+              <a:t>5 Whys</a:t>
+            </a:r>
+          </a:p>
+        </p:txBody>
+      </p:sp>
+      <p:sp>
+        <p:nvSpPr>
+          <p:cNvPr id="4" name="Rectangle 3"/>
+          <p:cNvSpPr/>
+          <p:nvPr/>
+        </p:nvSpPr>
+        <p:spPr>
+          <a:xfrm>
+            <a:off x="502920" y="941832"/>
+            <a:ext cx="11155680" cy="27432"/>
+          </a:xfrm>
+          <a:prstGeom prst="rect">
+            <a:avLst/>
+          </a:prstGeom>
+          <a:solidFill>
+            <a:srgbClr val="427E78"/>
+          </a:solidFill>
+          <a:ln>
+            <a:noFill/>
+          </a:ln>
+        </p:spPr>
+        <p:style>
+          <a:lnRef idx="1">
+            <a:schemeClr val="accent1"/>
+          </a:lnRef>
+          <a:fillRef idx="3">
+            <a:schemeClr val="accent1"/>
+          </a:fillRef>
+          <a:effectRef idx="2">
+            <a:schemeClr val="accent1"/>
+          </a:effectRef>
+          <a:fontRef idx="minor">
+            <a:schemeClr val="lt1"/>
+          </a:fontRef>
+        </p:style>
+        <p:txBody>
+          <a:bodyPr rtlCol="0" anchor="ctr"/>
+          <a:lstStyle/>
+          <a:p>
+            <a:pPr algn="ctr"/>
+          </a:p>
+        </p:txBody>
+      </p:sp>
+      <p:sp>
+        <p:nvSpPr>
+          <p:cNvPr id="5" name="Rounded Rectangle 4"/>
+          <p:cNvSpPr/>
+          <p:nvPr/>
+        </p:nvSpPr>
+        <p:spPr>
+          <a:xfrm>
+            <a:off x="640080" y="1051560"/>
+            <a:ext cx="4754880" cy="329184"/>
+          </a:xfrm>
+          <a:prstGeom prst="roundRect">
+            <a:avLst/>
+          </a:prstGeom>
+          <a:solidFill>
+            <a:srgbClr val="FFF2CC"/>
+          </a:solidFill>
+          <a:ln>
+            <a:solidFill>
+              <a:srgbClr val="D69F2E"/>
+            </a:solidFill>
+          </a:ln>
+        </p:spPr>
+        <p:style>
+          <a:lnRef idx="1">
+            <a:schemeClr val="accent1"/>
+          </a:lnRef>
+          <a:fillRef idx="3">
+            <a:schemeClr val="accent1"/>
+          </a:fillRef>
+          <a:effectRef idx="2">
+            <a:schemeClr val="accent1"/>
+          </a:effectRef>
+          <a:fontRef idx="minor">
+            <a:schemeClr val="lt1"/>
+          </a:fontRef>
+        </p:style>
+        <p:txBody>
+          <a:bodyPr rtlCol="0" anchor="ctr"/>
+          <a:lstStyle/>
+          <a:p>
+            <a:pPr algn="ctr"/>
+            <a:r>
+              <a:rPr b="1" sz="1100">
+                <a:solidFill>
+                  <a:srgbClr val="664B11"/>
+                </a:solidFill>
+              </a:rPr>
+              <a:t>Replace demo content with project evidence</a:t>
+            </a:r>
+          </a:p>
+        </p:txBody>
+      </p:sp>
+      <p:sp>
+        <p:nvSpPr>
+          <p:cNvPr id="6" name="Rounded Rectangle 5"/>
+          <p:cNvSpPr/>
+          <p:nvPr/>
+        </p:nvSpPr>
+        <p:spPr>
+          <a:xfrm>
+            <a:off x="640080" y="1691640"/>
+            <a:ext cx="5394960" cy="4206240"/>
+          </a:xfrm>
+          <a:prstGeom prst="roundRect">
+            <a:avLst/>
+          </a:prstGeom>
+          <a:solidFill>
+            <a:srgbClr val="F8F9F7"/>
+          </a:solidFill>
+          <a:ln>
+            <a:solidFill>
+              <a:srgbClr val="BEC4BF"/>
+            </a:solidFill>
+          </a:ln>
+        </p:spPr>
+        <p:style>
+          <a:lnRef idx="1">
+            <a:schemeClr val="accent1"/>
+          </a:lnRef>
+          <a:fillRef idx="3">
+            <a:schemeClr val="accent1"/>
+          </a:fillRef>
+          <a:effectRef idx="2">
+            <a:schemeClr val="accent1"/>
+          </a:effectRef>
+          <a:fontRef idx="minor">
+            <a:schemeClr val="lt1"/>
+          </a:fontRef>
+        </p:style>
+        <p:txBody>
+          <a:bodyPr rtlCol="0" anchor="t" lIns="164592" rIns="164592" tIns="128016"/>
+          <a:lstStyle/>
+          <a:p>
+            <a:pPr algn="ctr"/>
+            <a:r>
+              <a:rPr b="1" sz="1500">
+                <a:solidFill>
+                  <a:srgbClr val="1B2733"/>
+                </a:solidFill>
+              </a:rPr>
+              <a:t>Project slide checklist</a:t>
+            </a:r>
+          </a:p>
+          <a:p>
+            <a:pPr>
+              <a:defRPr sz="1100">
+                <a:solidFill>
+                  <a:srgbClr val="2D3741"/>
+                </a:solidFill>
+              </a:defRPr>
+            </a:pPr>
+            <a:r>
+              <a:t>Project title: [selected problem or cause]</a:t>
+            </a:r>
+          </a:p>
+          <a:p>
+            <a:pPr>
+              <a:defRPr sz="1100">
+                <a:solidFill>
+                  <a:srgbClr val="2D3741"/>
+                </a:solidFill>
+              </a:defRPr>
+            </a:pPr>
+            <a:r>
+              <a:t>Worksheet: replace demo why-chain answers.</a:t>
+            </a:r>
+          </a:p>
+          <a:p>
+            <a:pPr>
+              <a:defRPr sz="1100">
+                <a:solidFill>
+                  <a:srgbClr val="2D3741"/>
+                </a:solidFill>
+              </a:defRPr>
+            </a:pPr>
+            <a:r>
+              <a:t>Source: [observation, interview, record, or verification check]</a:t>
+            </a:r>
+          </a:p>
+          <a:p>
+            <a:pPr>
+              <a:defRPr sz="1100">
+                <a:solidFill>
+                  <a:srgbClr val="2D3741"/>
+                </a:solidFill>
+              </a:defRPr>
+            </a:pPr>
+            <a:r>
+              <a:t>Date range: [when evidence was checked]</a:t>
+            </a:r>
+          </a:p>
+          <a:p>
+            <a:pPr>
+              <a:defRPr sz="1100">
+                <a:solidFill>
+                  <a:srgbClr val="2D3741"/>
+                </a:solidFill>
+              </a:defRPr>
+            </a:pPr>
+            <a:r>
+              <a:t>Key conclusion: [candidate root cause and evidence status]</a:t>
+            </a:r>
+          </a:p>
+          <a:p>
+            <a:pPr>
+              <a:defRPr sz="1100">
+                <a:solidFill>
+                  <a:srgbClr val="2D3741"/>
+                </a:solidFill>
+              </a:defRPr>
+            </a:pPr>
+            <a:r>
+              <a:t>Next action: [verify cause or design countermeasure]</a:t>
+            </a:r>
+          </a:p>
+          <a:p>
+            <a:pPr>
+              <a:defRPr sz="1100">
+                <a:solidFill>
+                  <a:srgbClr val="2D3741"/>
+                </a:solidFill>
+              </a:defRPr>
+            </a:pPr>
+            <a:r>
+              <a:t>Prepared by/date: [name and date]</a:t>
+            </a:r>
+          </a:p>
+        </p:txBody>
+      </p:sp>
+      <p:sp>
+        <p:nvSpPr>
+          <p:cNvPr id="7" name="Rounded Rectangle 6"/>
+          <p:cNvSpPr/>
+          <p:nvPr/>
+        </p:nvSpPr>
+        <p:spPr>
+          <a:xfrm>
+            <a:off x="6355080" y="1691640"/>
+            <a:ext cx="4892040" cy="4206240"/>
+          </a:xfrm>
+          <a:prstGeom prst="roundRect">
+            <a:avLst/>
+          </a:prstGeom>
+          <a:solidFill>
+            <a:srgbClr val="F8F9F7"/>
+          </a:solidFill>
+          <a:ln>
+            <a:solidFill>
+              <a:srgbClr val="BEC4BF"/>
+            </a:solidFill>
+          </a:ln>
+        </p:spPr>
+        <p:style>
+          <a:lnRef idx="1">
+            <a:schemeClr val="accent1"/>
+          </a:lnRef>
+          <a:fillRef idx="3">
+            <a:schemeClr val="accent1"/>
+          </a:fillRef>
+          <a:effectRef idx="2">
+            <a:schemeClr val="accent1"/>
+          </a:effectRef>
+          <a:fontRef idx="minor">
+            <a:schemeClr val="lt1"/>
+          </a:fontRef>
+        </p:style>
+        <p:txBody>
+          <a:bodyPr rtlCol="0" anchor="t" lIns="164592" rIns="164592" tIns="128016"/>
+          <a:lstStyle/>
+          <a:p>
+            <a:pPr algn="ctr"/>
+            <a:r>
+              <a:rPr b="1" sz="1500">
+                <a:solidFill>
+                  <a:srgbClr val="1B2733"/>
+                </a:solidFill>
+              </a:rPr>
+              <a:t>Reserved placeholders</a:t>
+            </a:r>
+          </a:p>
+          <a:p>
+            <a:pPr>
+              <a:defRPr sz="1100">
+                <a:solidFill>
+                  <a:srgbClr val="2D3741"/>
+                </a:solidFill>
+              </a:defRPr>
+            </a:pPr>
+            <a:r>
+              <a:t>{{method_name}}</a:t>
+            </a:r>
+          </a:p>
+          <a:p>
+            <a:pPr>
+              <a:defRPr sz="1100">
+                <a:solidFill>
+                  <a:srgbClr val="2D3741"/>
+                </a:solidFill>
+              </a:defRPr>
+            </a:pPr>
+            <a:r>
+              <a:t>{{qcc_stage}}</a:t>
+            </a:r>
+          </a:p>
+          <a:p>
+            <a:pPr>
+              <a:defRPr sz="1100">
+                <a:solidFill>
+                  <a:srgbClr val="2D3741"/>
+                </a:solidFill>
+              </a:defRPr>
+            </a:pPr>
+            <a:r>
+              <a:t>{{demo_label}}</a:t>
+            </a:r>
+          </a:p>
+          <a:p>
+            <a:pPr>
+              <a:defRPr sz="1100">
+                <a:solidFill>
+                  <a:srgbClr val="2D3741"/>
+                </a:solidFill>
+              </a:defRPr>
+            </a:pPr>
+            <a:r>
+              <a:t>{{problem}}</a:t>
+            </a:r>
+          </a:p>
+          <a:p>
+            <a:pPr>
+              <a:defRPr sz="1100">
+                <a:solidFill>
+                  <a:srgbClr val="2D3741"/>
+                </a:solidFill>
+              </a:defRPr>
+            </a:pPr>
+            <a:r>
+              <a:t>{{why_chain}}</a:t>
+            </a:r>
+          </a:p>
+          <a:p>
+            <a:pPr>
+              <a:defRPr sz="1100">
+                <a:solidFill>
+                  <a:srgbClr val="2D3741"/>
+                </a:solidFill>
+              </a:defRPr>
+            </a:pPr>
+            <a:r>
+              <a:t>{{root_cause}}</a:t>
+            </a:r>
+          </a:p>
+          <a:p>
+            <a:pPr>
+              <a:defRPr sz="1100">
+                <a:solidFill>
+                  <a:srgbClr val="2D3741"/>
+                </a:solidFill>
+              </a:defRPr>
+            </a:pPr>
+            <a:r>
+              <a:t>{{verification}}</a:t>
+            </a:r>
+          </a:p>
+        </p:txBody>
+      </p:sp>
+      <p:sp>
+        <p:nvSpPr>
+          <p:cNvPr id="8" name="TextBox 7"/>
           <p:cNvSpPr txBox="1"/>
           <p:nvPr/>
         </p:nvSpPr>
@@ -4431,7 +4924,7 @@
                   <a:srgbClr val="1B2733"/>
                 </a:solidFill>
               </a:rPr>
-              <a:t>DEMO EXAMPLE - not project evidence</a:t>
+              <a:t>QCC stage fit and required inputs</a:t>
             </a:r>
           </a:p>
         </p:txBody>
@@ -4520,61 +5013,8 @@
         </p:nvSpPr>
         <p:spPr>
           <a:xfrm>
-            <a:off x="640080" y="1051560"/>
-            <a:ext cx="3840480" cy="329184"/>
-          </a:xfrm>
-          <a:prstGeom prst="roundRect">
-            <a:avLst/>
-          </a:prstGeom>
-          <a:solidFill>
-            <a:srgbClr val="FFF2CC"/>
-          </a:solidFill>
-          <a:ln>
-            <a:solidFill>
-              <a:srgbClr val="D69F2E"/>
-            </a:solidFill>
-          </a:ln>
-        </p:spPr>
-        <p:style>
-          <a:lnRef idx="1">
-            <a:schemeClr val="accent1"/>
-          </a:lnRef>
-          <a:fillRef idx="3">
-            <a:schemeClr val="accent1"/>
-          </a:fillRef>
-          <a:effectRef idx="2">
-            <a:schemeClr val="accent1"/>
-          </a:effectRef>
-          <a:fontRef idx="minor">
-            <a:schemeClr val="lt1"/>
-          </a:fontRef>
-        </p:style>
-        <p:txBody>
-          <a:bodyPr rtlCol="0" anchor="ctr"/>
-          <a:lstStyle/>
-          <a:p>
-            <a:pPr algn="ctr"/>
-            <a:r>
-              <a:rPr b="1" sz="1100">
-                <a:solidFill>
-                  <a:srgbClr val="664B11"/>
-                </a:solidFill>
-              </a:rPr>
-              <a:t>DEMO EXAMPLE - not project evidence</a:t>
-            </a:r>
-          </a:p>
-        </p:txBody>
-      </p:sp>
-      <p:sp>
-        <p:nvSpPr>
-          <p:cNvPr id="6" name="Rounded Rectangle 5"/>
-          <p:cNvSpPr/>
-          <p:nvPr/>
-        </p:nvSpPr>
-        <p:spPr>
-          <a:xfrm>
-            <a:off x="640080" y="1691640"/>
-            <a:ext cx="5394960" cy="4206240"/>
+            <a:off x="640080" y="1325880"/>
+            <a:ext cx="5212080" cy="4526280"/>
           </a:xfrm>
           <a:prstGeom prst="roundRect">
             <a:avLst/>
@@ -4613,81 +5053,57 @@
                   <a:srgbClr val="1B2733"/>
                 </a:solidFill>
               </a:rPr>
-              <a:t>Demo structure</a:t>
-            </a:r>
-          </a:p>
-          <a:p>
-            <a:pPr>
-              <a:defRPr sz="1100">
-                <a:solidFill>
-                  <a:srgbClr val="2D3741"/>
-                </a:solidFill>
-              </a:defRPr>
-            </a:pPr>
-            <a:r>
-              <a:t>Change data only: replace the why-chain answers and evidence checks.</a:t>
-            </a:r>
-          </a:p>
-          <a:p>
-            <a:pPr>
-              <a:defRPr sz="1100">
-                <a:solidFill>
-                  <a:srgbClr val="2D3741"/>
-                </a:solidFill>
-              </a:defRPr>
-            </a:pPr>
-            <a:r>
-              <a:t>Problem: {{problem}}</a:t>
-            </a:r>
-          </a:p>
-          <a:p>
-            <a:pPr>
-              <a:defRPr sz="1100">
-                <a:solidFill>
-                  <a:srgbClr val="2D3741"/>
-                </a:solidFill>
-              </a:defRPr>
-            </a:pPr>
-            <a:r>
-              <a:t>Why chain: {{why_chain}}</a:t>
-            </a:r>
-          </a:p>
-          <a:p>
-            <a:pPr>
-              <a:defRPr sz="1100">
-                <a:solidFill>
-                  <a:srgbClr val="2D3741"/>
-                </a:solidFill>
-              </a:defRPr>
-            </a:pPr>
-            <a:r>
-              <a:t>Root cause: {{root_cause}}</a:t>
-            </a:r>
-          </a:p>
-          <a:p>
-            <a:pPr>
-              <a:defRPr sz="1100">
-                <a:solidFill>
-                  <a:srgbClr val="2D3741"/>
-                </a:solidFill>
-              </a:defRPr>
-            </a:pPr>
-            <a:r>
-              <a:t>Verification: {{verification}}</a:t>
-            </a:r>
-          </a:p>
-        </p:txBody>
-      </p:sp>
-      <p:sp>
-        <p:nvSpPr>
-          <p:cNvPr id="7" name="Rounded Rectangle 6"/>
+              <a:t>QCC stage fit</a:t>
+            </a:r>
+          </a:p>
+          <a:p>
+            <a:pPr>
+              <a:defRPr sz="1100">
+                <a:solidFill>
+                  <a:srgbClr val="2D3741"/>
+                </a:solidFill>
+              </a:defRPr>
+            </a:pPr>
+            <a:r>
+              <a:t>Analyze Causes: deepen one selected problem or cause.</a:t>
+            </a:r>
+          </a:p>
+          <a:p>
+            <a:pPr>
+              <a:defRPr sz="1100">
+                <a:solidFill>
+                  <a:srgbClr val="2D3741"/>
+                </a:solidFill>
+              </a:defRPr>
+            </a:pPr>
+            <a:r>
+              <a:t>Use after 5W2H, Pareto, or Fishbone narrows focus.</a:t>
+            </a:r>
+          </a:p>
+          <a:p>
+            <a:pPr>
+              <a:defRPr sz="1100">
+                <a:solidFill>
+                  <a:srgbClr val="2D3741"/>
+                </a:solidFill>
+              </a:defRPr>
+            </a:pPr>
+            <a:r>
+              <a:t>A why chain needs evidence before countermeasures.</a:t>
+            </a:r>
+          </a:p>
+        </p:txBody>
+      </p:sp>
+      <p:sp>
+        <p:nvSpPr>
+          <p:cNvPr id="6" name="Rounded Rectangle 5"/>
           <p:cNvSpPr/>
           <p:nvPr/>
         </p:nvSpPr>
         <p:spPr>
           <a:xfrm>
-            <a:off x="6355080" y="1691640"/>
-            <a:ext cx="4892040" cy="4206240"/>
+            <a:off x="6263640" y="1325880"/>
+            <a:ext cx="5212080" cy="4526280"/>
           </a:xfrm>
           <a:prstGeom prst="roundRect">
             <a:avLst/>
@@ -4726,98 +5142,62 @@
                   <a:srgbClr val="1B2733"/>
                 </a:solidFill>
               </a:rPr>
-              <a:t>Reserved placeholders</a:t>
-            </a:r>
-          </a:p>
-          <a:p>
-            <a:pPr>
-              <a:defRPr sz="1100">
-                <a:solidFill>
-                  <a:srgbClr val="2D3741"/>
-                </a:solidFill>
-              </a:defRPr>
-            </a:pPr>
-            <a:r>
-              <a:t>{{method_name}}</a:t>
-            </a:r>
-          </a:p>
-          <a:p>
-            <a:pPr>
-              <a:defRPr sz="1100">
-                <a:solidFill>
-                  <a:srgbClr val="2D3741"/>
-                </a:solidFill>
-              </a:defRPr>
-            </a:pPr>
-            <a:r>
-              <a:t>{{qcc_stage}}</a:t>
-            </a:r>
-          </a:p>
-          <a:p>
-            <a:pPr>
-              <a:defRPr sz="1100">
-                <a:solidFill>
-                  <a:srgbClr val="2D3741"/>
-                </a:solidFill>
-              </a:defRPr>
-            </a:pPr>
-            <a:r>
-              <a:t>{{demo_label}}</a:t>
-            </a:r>
-          </a:p>
-          <a:p>
-            <a:pPr>
-              <a:defRPr sz="1100">
-                <a:solidFill>
-                  <a:srgbClr val="2D3741"/>
-                </a:solidFill>
-              </a:defRPr>
-            </a:pPr>
-            <a:r>
-              <a:t>{{problem}}</a:t>
-            </a:r>
-          </a:p>
-          <a:p>
-            <a:pPr>
-              <a:defRPr sz="1100">
-                <a:solidFill>
-                  <a:srgbClr val="2D3741"/>
-                </a:solidFill>
-              </a:defRPr>
-            </a:pPr>
-            <a:r>
-              <a:t>{{why_chain}}</a:t>
-            </a:r>
-          </a:p>
-          <a:p>
-            <a:pPr>
-              <a:defRPr sz="1100">
-                <a:solidFill>
-                  <a:srgbClr val="2D3741"/>
-                </a:solidFill>
-              </a:defRPr>
-            </a:pPr>
-            <a:r>
-              <a:t>{{root_cause}}</a:t>
-            </a:r>
-          </a:p>
-          <a:p>
-            <a:pPr>
-              <a:defRPr sz="1100">
-                <a:solidFill>
-                  <a:srgbClr val="2D3741"/>
-                </a:solidFill>
-              </a:defRPr>
-            </a:pPr>
-            <a:r>
-              <a:t>{{verification}}</a:t>
-            </a:r>
-          </a:p>
-        </p:txBody>
-      </p:sp>
-      <p:sp>
-        <p:nvSpPr>
-          <p:cNvPr id="8" name="TextBox 7"/>
+              <a:t>Required inputs</a:t>
+            </a:r>
+          </a:p>
+          <a:p>
+            <a:pPr>
+              <a:defRPr sz="1100">
+                <a:solidFill>
+                  <a:srgbClr val="2D3741"/>
+                </a:solidFill>
+              </a:defRPr>
+            </a:pPr>
+            <a:r>
+              <a:t>Narrow starting problem.</a:t>
+            </a:r>
+          </a:p>
+          <a:p>
+            <a:pPr>
+              <a:defRPr sz="1100">
+                <a:solidFill>
+                  <a:srgbClr val="2D3741"/>
+                </a:solidFill>
+              </a:defRPr>
+            </a:pPr>
+            <a:r>
+              <a:t>Why answers and evidence checks.</a:t>
+            </a:r>
+          </a:p>
+          <a:p>
+            <a:pPr>
+              <a:defRPr sz="1100">
+                <a:solidFill>
+                  <a:srgbClr val="2D3741"/>
+                </a:solidFill>
+              </a:defRPr>
+            </a:pPr>
+            <a:r>
+              <a:t>Candidate root cause.</a:t>
+            </a:r>
+          </a:p>
+          <a:p>
+            <a:pPr>
+              <a:defRPr sz="1100">
+                <a:solidFill>
+                  <a:srgbClr val="2D3741"/>
+                </a:solidFill>
+              </a:defRPr>
+            </a:pPr>
+            <a:r>
+              <a:t>Source, date range, and verification status.</a:t>
+            </a:r>
+          </a:p>
+        </p:txBody>
+      </p:sp>
+      <p:sp>
+        <p:nvSpPr>
+          <p:cNvPr id="7" name="TextBox 6"/>
           <p:cNvSpPr txBox="1"/>
           <p:nvPr/>
         </p:nvSpPr>
@@ -4894,7 +5274,7 @@
                   <a:srgbClr val="1B2733"/>
                 </a:solidFill>
               </a:rPr>
-              <a:t>Project Why Chain</a:t>
+              <a:t>When to use and when not to use</a:t>
             </a:r>
           </a:p>
         </p:txBody>
@@ -4983,8 +5363,1794 @@
         </p:nvSpPr>
         <p:spPr>
           <a:xfrm>
+            <a:off x="640080" y="1325880"/>
+            <a:ext cx="5212080" cy="4526280"/>
+          </a:xfrm>
+          <a:prstGeom prst="roundRect">
+            <a:avLst/>
+          </a:prstGeom>
+          <a:solidFill>
+            <a:srgbClr val="F8F9F7"/>
+          </a:solidFill>
+          <a:ln>
+            <a:solidFill>
+              <a:srgbClr val="BEC4BF"/>
+            </a:solidFill>
+          </a:ln>
+        </p:spPr>
+        <p:style>
+          <a:lnRef idx="1">
+            <a:schemeClr val="accent1"/>
+          </a:lnRef>
+          <a:fillRef idx="3">
+            <a:schemeClr val="accent1"/>
+          </a:fillRef>
+          <a:effectRef idx="2">
+            <a:schemeClr val="accent1"/>
+          </a:effectRef>
+          <a:fontRef idx="minor">
+            <a:schemeClr val="lt1"/>
+          </a:fontRef>
+        </p:style>
+        <p:txBody>
+          <a:bodyPr rtlCol="0" anchor="t" lIns="164592" rIns="164592" tIns="128016"/>
+          <a:lstStyle/>
+          <a:p>
+            <a:pPr algn="ctr"/>
+            <a:r>
+              <a:rPr b="1" sz="1500">
+                <a:solidFill>
+                  <a:srgbClr val="1B2733"/>
+                </a:solidFill>
+              </a:rPr>
+              <a:t>When to use</a:t>
+            </a:r>
+          </a:p>
+          <a:p>
+            <a:pPr>
+              <a:defRPr sz="1100">
+                <a:solidFill>
+                  <a:srgbClr val="2D3741"/>
+                </a:solidFill>
+              </a:defRPr>
+            </a:pPr>
+            <a:r>
+              <a:t>The team can follow one cause chain.</a:t>
+            </a:r>
+          </a:p>
+          <a:p>
+            <a:pPr>
+              <a:defRPr sz="1100">
+                <a:solidFill>
+                  <a:srgbClr val="2D3741"/>
+                </a:solidFill>
+              </a:defRPr>
+            </a:pPr>
+            <a:r>
+              <a:t>Each answer can be checked.</a:t>
+            </a:r>
+          </a:p>
+          <a:p>
+            <a:pPr>
+              <a:defRPr sz="1100">
+                <a:solidFill>
+                  <a:srgbClr val="2D3741"/>
+                </a:solidFill>
+              </a:defRPr>
+            </a:pPr>
+            <a:r>
+              <a:t>The output will guide verification or countermeasures.</a:t>
+            </a:r>
+          </a:p>
+        </p:txBody>
+      </p:sp>
+      <p:sp>
+        <p:nvSpPr>
+          <p:cNvPr id="6" name="Rounded Rectangle 5"/>
+          <p:cNvSpPr/>
+          <p:nvPr/>
+        </p:nvSpPr>
+        <p:spPr>
+          <a:xfrm>
+            <a:off x="6263640" y="1325880"/>
+            <a:ext cx="5212080" cy="4526280"/>
+          </a:xfrm>
+          <a:prstGeom prst="roundRect">
+            <a:avLst/>
+          </a:prstGeom>
+          <a:solidFill>
+            <a:srgbClr val="F8F9F7"/>
+          </a:solidFill>
+          <a:ln>
+            <a:solidFill>
+              <a:srgbClr val="BEC4BF"/>
+            </a:solidFill>
+          </a:ln>
+        </p:spPr>
+        <p:style>
+          <a:lnRef idx="1">
+            <a:schemeClr val="accent1"/>
+          </a:lnRef>
+          <a:fillRef idx="3">
+            <a:schemeClr val="accent1"/>
+          </a:fillRef>
+          <a:effectRef idx="2">
+            <a:schemeClr val="accent1"/>
+          </a:effectRef>
+          <a:fontRef idx="minor">
+            <a:schemeClr val="lt1"/>
+          </a:fontRef>
+        </p:style>
+        <p:txBody>
+          <a:bodyPr rtlCol="0" anchor="t" lIns="164592" rIns="164592" tIns="128016"/>
+          <a:lstStyle/>
+          <a:p>
+            <a:pPr algn="ctr"/>
+            <a:r>
+              <a:rPr b="1" sz="1500">
+                <a:solidFill>
+                  <a:srgbClr val="1B2733"/>
+                </a:solidFill>
+              </a:rPr>
+              <a:t>When not to use</a:t>
+            </a:r>
+          </a:p>
+          <a:p>
+            <a:pPr>
+              <a:defRPr sz="1100">
+                <a:solidFill>
+                  <a:srgbClr val="2D3741"/>
+                </a:solidFill>
+              </a:defRPr>
+            </a:pPr>
+            <a:r>
+              <a:t>The problem has many independent branches.</a:t>
+            </a:r>
+          </a:p>
+          <a:p>
+            <a:pPr>
+              <a:defRPr sz="1100">
+                <a:solidFill>
+                  <a:srgbClr val="2D3741"/>
+                </a:solidFill>
+              </a:defRPr>
+            </a:pPr>
+            <a:r>
+              <a:t>Answers are opinions with no evidence path.</a:t>
+            </a:r>
+          </a:p>
+          <a:p>
+            <a:pPr>
+              <a:defRPr sz="1100">
+                <a:solidFill>
+                  <a:srgbClr val="2D3741"/>
+                </a:solidFill>
+              </a:defRPr>
+            </a:pPr>
+            <a:r>
+              <a:t>The fifth answer is assumed true without verification.</a:t>
+            </a:r>
+          </a:p>
+        </p:txBody>
+      </p:sp>
+      <p:sp>
+        <p:nvSpPr>
+          <p:cNvPr id="7" name="TextBox 6"/>
+          <p:cNvSpPr txBox="1"/>
+          <p:nvPr/>
+        </p:nvSpPr>
+        <p:spPr>
+          <a:xfrm>
+            <a:off x="548640" y="6355080"/>
+            <a:ext cx="10881360" cy="228600"/>
+          </a:xfrm>
+          <a:prstGeom prst="rect">
+            <a:avLst/>
+          </a:prstGeom>
+          <a:noFill/>
+        </p:spPr>
+        <p:txBody>
+          <a:bodyPr wrap="square" lIns="73152" rIns="73152">
+            <a:spAutoFit/>
+          </a:bodyPr>
+          <a:lstStyle/>
+          <a:p>
+            <a:r>
+              <a:rPr sz="800" b="0">
+                <a:solidFill>
+                  <a:srgbClr val="697077"/>
+                </a:solidFill>
+              </a:rPr>
+              <a:t>5_whys_method_template | 5_whys | Final data-dependent evidence belongs in the evidence package.</a:t>
+            </a:r>
+          </a:p>
+        </p:txBody>
+      </p:sp>
+    </p:spTree>
+  </p:cSld>
+  <p:clrMapOvr>
+    <a:masterClrMapping/>
+  </p:clrMapOvr>
+</p:sld>
+</file>
+
+<file path=ppt/slides/slide5.xml><?xml version="1.0" encoding="utf-8"?>
+<p:sld xmlns:a="http://schemas.openxmlformats.org/drawingml/2006/main" xmlns:p="http://schemas.openxmlformats.org/presentationml/2006/main" xmlns:r="http://schemas.openxmlformats.org/officeDocument/2006/relationships">
+  <p:cSld>
+    <p:spTree>
+      <p:nvGrpSpPr>
+        <p:cNvPr id="1" name=""/>
+        <p:cNvGrpSpPr/>
+        <p:nvPr/>
+      </p:nvGrpSpPr>
+      <p:grpSpPr/>
+      <p:sp>
+        <p:nvSpPr>
+          <p:cNvPr id="2" name="TextBox 1"/>
+          <p:cNvSpPr txBox="1"/>
+          <p:nvPr/>
+        </p:nvSpPr>
+        <p:spPr>
+          <a:xfrm>
+            <a:off x="502920" y="256032"/>
+            <a:ext cx="8321040" cy="420624"/>
+          </a:xfrm>
+          <a:prstGeom prst="rect">
+            <a:avLst/>
+          </a:prstGeom>
+          <a:noFill/>
+        </p:spPr>
+        <p:txBody>
+          <a:bodyPr wrap="square" lIns="73152" rIns="73152">
+            <a:spAutoFit/>
+          </a:bodyPr>
+          <a:lstStyle/>
+          <a:p>
+            <a:r>
+              <a:rPr sz="2400" b="1">
+                <a:solidFill>
+                  <a:srgbClr val="1B2733"/>
+                </a:solidFill>
+              </a:rPr>
+              <a:t>Blank working slide or worksheet</a:t>
+            </a:r>
+          </a:p>
+        </p:txBody>
+      </p:sp>
+      <p:sp>
+        <p:nvSpPr>
+          <p:cNvPr id="3" name="TextBox 2"/>
+          <p:cNvSpPr txBox="1"/>
+          <p:nvPr/>
+        </p:nvSpPr>
+        <p:spPr>
+          <a:xfrm>
+            <a:off x="521207" y="713232"/>
+            <a:ext cx="7772400" cy="237744"/>
+          </a:xfrm>
+          <a:prstGeom prst="rect">
+            <a:avLst/>
+          </a:prstGeom>
+          <a:noFill/>
+        </p:spPr>
+        <p:txBody>
+          <a:bodyPr wrap="square" lIns="73152" rIns="73152">
+            <a:spAutoFit/>
+          </a:bodyPr>
+          <a:lstStyle/>
+          <a:p>
+            <a:r>
+              <a:rPr sz="1100" b="0">
+                <a:solidFill>
+                  <a:srgbClr val="5A636C"/>
+                </a:solidFill>
+              </a:rPr>
+              <a:t>5 Whys</a:t>
+            </a:r>
+          </a:p>
+        </p:txBody>
+      </p:sp>
+      <p:sp>
+        <p:nvSpPr>
+          <p:cNvPr id="4" name="Rectangle 3"/>
+          <p:cNvSpPr/>
+          <p:nvPr/>
+        </p:nvSpPr>
+        <p:spPr>
+          <a:xfrm>
+            <a:off x="502920" y="941832"/>
+            <a:ext cx="11155680" cy="27432"/>
+          </a:xfrm>
+          <a:prstGeom prst="rect">
+            <a:avLst/>
+          </a:prstGeom>
+          <a:solidFill>
+            <a:srgbClr val="427E78"/>
+          </a:solidFill>
+          <a:ln>
+            <a:noFill/>
+          </a:ln>
+        </p:spPr>
+        <p:style>
+          <a:lnRef idx="1">
+            <a:schemeClr val="accent1"/>
+          </a:lnRef>
+          <a:fillRef idx="3">
+            <a:schemeClr val="accent1"/>
+          </a:fillRef>
+          <a:effectRef idx="2">
+            <a:schemeClr val="accent1"/>
+          </a:effectRef>
+          <a:fontRef idx="minor">
+            <a:schemeClr val="lt1"/>
+          </a:fontRef>
+        </p:style>
+        <p:txBody>
+          <a:bodyPr rtlCol="0" anchor="ctr"/>
+          <a:lstStyle/>
+          <a:p>
+            <a:pPr algn="ctr"/>
+          </a:p>
+        </p:txBody>
+      </p:sp>
+      <p:sp>
+        <p:nvSpPr>
+          <p:cNvPr id="5" name="Rounded Rectangle 4"/>
+          <p:cNvSpPr/>
+          <p:nvPr/>
+        </p:nvSpPr>
+        <p:spPr>
+          <a:xfrm>
+            <a:off x="640080" y="1325880"/>
+            <a:ext cx="5212080" cy="4526280"/>
+          </a:xfrm>
+          <a:prstGeom prst="roundRect">
+            <a:avLst/>
+          </a:prstGeom>
+          <a:solidFill>
+            <a:srgbClr val="F8F9F7"/>
+          </a:solidFill>
+          <a:ln>
+            <a:solidFill>
+              <a:srgbClr val="BEC4BF"/>
+            </a:solidFill>
+          </a:ln>
+        </p:spPr>
+        <p:style>
+          <a:lnRef idx="1">
+            <a:schemeClr val="accent1"/>
+          </a:lnRef>
+          <a:fillRef idx="3">
+            <a:schemeClr val="accent1"/>
+          </a:fillRef>
+          <a:effectRef idx="2">
+            <a:schemeClr val="accent1"/>
+          </a:effectRef>
+          <a:fontRef idx="minor">
+            <a:schemeClr val="lt1"/>
+          </a:fontRef>
+        </p:style>
+        <p:txBody>
+          <a:bodyPr rtlCol="0" anchor="t" lIns="164592" rIns="164592" tIns="128016"/>
+          <a:lstStyle/>
+          <a:p>
+            <a:pPr algn="ctr"/>
+            <a:r>
+              <a:rPr b="1" sz="1500">
+                <a:solidFill>
+                  <a:srgbClr val="1B2733"/>
+                </a:solidFill>
+              </a:rPr>
+              <a:t>Completed demo example</a:t>
+            </a:r>
+          </a:p>
+          <a:p>
+            <a:pPr>
+              <a:defRPr sz="1100">
+                <a:solidFill>
+                  <a:srgbClr val="2D3741"/>
+                </a:solidFill>
+              </a:defRPr>
+            </a:pPr>
+            <a:r>
+              <a:t>Review the completed demo example before editing.</a:t>
+            </a:r>
+          </a:p>
+          <a:p>
+            <a:pPr>
+              <a:defRPr sz="1100">
+                <a:solidFill>
+                  <a:srgbClr val="2D3741"/>
+                </a:solidFill>
+              </a:defRPr>
+            </a:pPr>
+            <a:r>
+              <a:t>DEMO EXAMPLE - not project evidence.</a:t>
+            </a:r>
+          </a:p>
+          <a:p>
+            <a:pPr>
+              <a:defRPr sz="1100">
+                <a:solidFill>
+                  <a:srgbClr val="2D3741"/>
+                </a:solidFill>
+              </a:defRPr>
+            </a:pPr>
+            <a:r>
+              <a:t>Copy the blank working slide or worksheet for project use.</a:t>
+            </a:r>
+          </a:p>
+          <a:p>
+            <a:pPr>
+              <a:defRPr sz="1100">
+                <a:solidFill>
+                  <a:srgbClr val="2D3741"/>
+                </a:solidFill>
+              </a:defRPr>
+            </a:pPr>
+            <a:r>
+              <a:t>Replace demo text with project facts.</a:t>
+            </a:r>
+          </a:p>
+        </p:txBody>
+      </p:sp>
+      <p:sp>
+        <p:nvSpPr>
+          <p:cNvPr id="6" name="Rounded Rectangle 5"/>
+          <p:cNvSpPr/>
+          <p:nvPr/>
+        </p:nvSpPr>
+        <p:spPr>
+          <a:xfrm>
+            <a:off x="6263640" y="1325880"/>
+            <a:ext cx="5212080" cy="4526280"/>
+          </a:xfrm>
+          <a:prstGeom prst="roundRect">
+            <a:avLst/>
+          </a:prstGeom>
+          <a:solidFill>
+            <a:srgbClr val="F8F9F7"/>
+          </a:solidFill>
+          <a:ln>
+            <a:solidFill>
+              <a:srgbClr val="BEC4BF"/>
+            </a:solidFill>
+          </a:ln>
+        </p:spPr>
+        <p:style>
+          <a:lnRef idx="1">
+            <a:schemeClr val="accent1"/>
+          </a:lnRef>
+          <a:fillRef idx="3">
+            <a:schemeClr val="accent1"/>
+          </a:fillRef>
+          <a:effectRef idx="2">
+            <a:schemeClr val="accent1"/>
+          </a:effectRef>
+          <a:fontRef idx="minor">
+            <a:schemeClr val="lt1"/>
+          </a:fontRef>
+        </p:style>
+        <p:txBody>
+          <a:bodyPr rtlCol="0" anchor="t" lIns="164592" rIns="164592" tIns="128016"/>
+          <a:lstStyle/>
+          <a:p>
+            <a:pPr algn="ctr"/>
+            <a:r>
+              <a:rPr b="1" sz="1500">
+                <a:solidFill>
+                  <a:srgbClr val="1B2733"/>
+                </a:solidFill>
+              </a:rPr>
+              <a:t>Blank working slide or worksheet</a:t>
+            </a:r>
+          </a:p>
+          <a:p>
+            <a:pPr>
+              <a:defRPr sz="1100">
+                <a:solidFill>
+                  <a:srgbClr val="2D3741"/>
+                </a:solidFill>
+              </a:defRPr>
+            </a:pPr>
+            <a:r>
+              <a:t>Keep method labels visible.</a:t>
+            </a:r>
+          </a:p>
+          <a:p>
+            <a:pPr>
+              <a:defRPr sz="1100">
+                <a:solidFill>
+                  <a:srgbClr val="2D3741"/>
+                </a:solidFill>
+              </a:defRPr>
+            </a:pPr>
+            <a:r>
+              <a:t>Record source and date range.</a:t>
+            </a:r>
+          </a:p>
+          <a:p>
+            <a:pPr>
+              <a:defRPr sz="1100">
+                <a:solidFill>
+                  <a:srgbClr val="2D3741"/>
+                </a:solidFill>
+              </a:defRPr>
+            </a:pPr>
+            <a:r>
+              <a:t>Write Key conclusion.</a:t>
+            </a:r>
+          </a:p>
+          <a:p>
+            <a:pPr>
+              <a:defRPr sz="1100">
+                <a:solidFill>
+                  <a:srgbClr val="2D3741"/>
+                </a:solidFill>
+              </a:defRPr>
+            </a:pPr>
+            <a:r>
+              <a:t>Write Next action.</a:t>
+            </a:r>
+          </a:p>
+        </p:txBody>
+      </p:sp>
+      <p:sp>
+        <p:nvSpPr>
+          <p:cNvPr id="7" name="TextBox 6"/>
+          <p:cNvSpPr txBox="1"/>
+          <p:nvPr/>
+        </p:nvSpPr>
+        <p:spPr>
+          <a:xfrm>
+            <a:off x="548640" y="6355080"/>
+            <a:ext cx="10881360" cy="228600"/>
+          </a:xfrm>
+          <a:prstGeom prst="rect">
+            <a:avLst/>
+          </a:prstGeom>
+          <a:noFill/>
+        </p:spPr>
+        <p:txBody>
+          <a:bodyPr wrap="square" lIns="73152" rIns="73152">
+            <a:spAutoFit/>
+          </a:bodyPr>
+          <a:lstStyle/>
+          <a:p>
+            <a:r>
+              <a:rPr sz="800" b="0">
+                <a:solidFill>
+                  <a:srgbClr val="697077"/>
+                </a:solidFill>
+              </a:rPr>
+              <a:t>5_whys_method_template | 5_whys | Final data-dependent evidence belongs in the evidence package.</a:t>
+            </a:r>
+          </a:p>
+        </p:txBody>
+      </p:sp>
+    </p:spTree>
+  </p:cSld>
+  <p:clrMapOvr>
+    <a:masterClrMapping/>
+  </p:clrMapOvr>
+</p:sld>
+</file>
+
+<file path=ppt/slides/slide6.xml><?xml version="1.0" encoding="utf-8"?>
+<p:sld xmlns:a="http://schemas.openxmlformats.org/drawingml/2006/main" xmlns:p="http://schemas.openxmlformats.org/presentationml/2006/main" xmlns:r="http://schemas.openxmlformats.org/officeDocument/2006/relationships">
+  <p:cSld>
+    <p:spTree>
+      <p:nvGrpSpPr>
+        <p:cNvPr id="1" name=""/>
+        <p:cNvGrpSpPr/>
+        <p:nvPr/>
+      </p:nvGrpSpPr>
+      <p:grpSpPr/>
+      <p:sp>
+        <p:nvSpPr>
+          <p:cNvPr id="2" name="TextBox 1"/>
+          <p:cNvSpPr txBox="1"/>
+          <p:nvPr/>
+        </p:nvSpPr>
+        <p:spPr>
+          <a:xfrm>
+            <a:off x="502920" y="256032"/>
+            <a:ext cx="8321040" cy="420624"/>
+          </a:xfrm>
+          <a:prstGeom prst="rect">
+            <a:avLst/>
+          </a:prstGeom>
+          <a:noFill/>
+        </p:spPr>
+        <p:txBody>
+          <a:bodyPr wrap="square" lIns="73152" rIns="73152">
+            <a:spAutoFit/>
+          </a:bodyPr>
+          <a:lstStyle/>
+          <a:p>
+            <a:r>
+              <a:rPr sz="2400" b="1">
+                <a:solidFill>
+                  <a:srgbClr val="1B2733"/>
+                </a:solidFill>
+              </a:rPr>
+              <a:t>Interpretation patterns and common mistakes</a:t>
+            </a:r>
+          </a:p>
+        </p:txBody>
+      </p:sp>
+      <p:sp>
+        <p:nvSpPr>
+          <p:cNvPr id="3" name="TextBox 2"/>
+          <p:cNvSpPr txBox="1"/>
+          <p:nvPr/>
+        </p:nvSpPr>
+        <p:spPr>
+          <a:xfrm>
+            <a:off x="521207" y="713232"/>
+            <a:ext cx="7772400" cy="237744"/>
+          </a:xfrm>
+          <a:prstGeom prst="rect">
+            <a:avLst/>
+          </a:prstGeom>
+          <a:noFill/>
+        </p:spPr>
+        <p:txBody>
+          <a:bodyPr wrap="square" lIns="73152" rIns="73152">
+            <a:spAutoFit/>
+          </a:bodyPr>
+          <a:lstStyle/>
+          <a:p>
+            <a:r>
+              <a:rPr sz="1100" b="0">
+                <a:solidFill>
+                  <a:srgbClr val="5A636C"/>
+                </a:solidFill>
+              </a:rPr>
+              <a:t>5 Whys</a:t>
+            </a:r>
+          </a:p>
+        </p:txBody>
+      </p:sp>
+      <p:sp>
+        <p:nvSpPr>
+          <p:cNvPr id="4" name="Rectangle 3"/>
+          <p:cNvSpPr/>
+          <p:nvPr/>
+        </p:nvSpPr>
+        <p:spPr>
+          <a:xfrm>
+            <a:off x="502920" y="941832"/>
+            <a:ext cx="11155680" cy="27432"/>
+          </a:xfrm>
+          <a:prstGeom prst="rect">
+            <a:avLst/>
+          </a:prstGeom>
+          <a:solidFill>
+            <a:srgbClr val="427E78"/>
+          </a:solidFill>
+          <a:ln>
+            <a:noFill/>
+          </a:ln>
+        </p:spPr>
+        <p:style>
+          <a:lnRef idx="1">
+            <a:schemeClr val="accent1"/>
+          </a:lnRef>
+          <a:fillRef idx="3">
+            <a:schemeClr val="accent1"/>
+          </a:fillRef>
+          <a:effectRef idx="2">
+            <a:schemeClr val="accent1"/>
+          </a:effectRef>
+          <a:fontRef idx="minor">
+            <a:schemeClr val="lt1"/>
+          </a:fontRef>
+        </p:style>
+        <p:txBody>
+          <a:bodyPr rtlCol="0" anchor="ctr"/>
+          <a:lstStyle/>
+          <a:p>
+            <a:pPr algn="ctr"/>
+          </a:p>
+        </p:txBody>
+      </p:sp>
+      <p:sp>
+        <p:nvSpPr>
+          <p:cNvPr id="5" name="Rounded Rectangle 4"/>
+          <p:cNvSpPr/>
+          <p:nvPr/>
+        </p:nvSpPr>
+        <p:spPr>
+          <a:xfrm>
+            <a:off x="640080" y="1325880"/>
+            <a:ext cx="5212080" cy="4526280"/>
+          </a:xfrm>
+          <a:prstGeom prst="roundRect">
+            <a:avLst/>
+          </a:prstGeom>
+          <a:solidFill>
+            <a:srgbClr val="F8F9F7"/>
+          </a:solidFill>
+          <a:ln>
+            <a:solidFill>
+              <a:srgbClr val="BEC4BF"/>
+            </a:solidFill>
+          </a:ln>
+        </p:spPr>
+        <p:style>
+          <a:lnRef idx="1">
+            <a:schemeClr val="accent1"/>
+          </a:lnRef>
+          <a:fillRef idx="3">
+            <a:schemeClr val="accent1"/>
+          </a:fillRef>
+          <a:effectRef idx="2">
+            <a:schemeClr val="accent1"/>
+          </a:effectRef>
+          <a:fontRef idx="minor">
+            <a:schemeClr val="lt1"/>
+          </a:fontRef>
+        </p:style>
+        <p:txBody>
+          <a:bodyPr rtlCol="0" anchor="t" lIns="164592" rIns="164592" tIns="128016"/>
+          <a:lstStyle/>
+          <a:p>
+            <a:pPr algn="ctr"/>
+            <a:r>
+              <a:rPr b="1" sz="1500">
+                <a:solidFill>
+                  <a:srgbClr val="1B2733"/>
+                </a:solidFill>
+              </a:rPr>
+              <a:t>Interpretation patterns</a:t>
+            </a:r>
+          </a:p>
+          <a:p>
+            <a:pPr>
+              <a:defRPr sz="1100">
+                <a:solidFill>
+                  <a:srgbClr val="2D3741"/>
+                </a:solidFill>
+              </a:defRPr>
+            </a:pPr>
+            <a:r>
+              <a:t>Cause chain: summarize the evidence-backed path.</a:t>
+            </a:r>
+          </a:p>
+          <a:p>
+            <a:pPr>
+              <a:defRPr sz="1100">
+                <a:solidFill>
+                  <a:srgbClr val="2D3741"/>
+                </a:solidFill>
+              </a:defRPr>
+            </a:pPr>
+            <a:r>
+              <a:t>Root-cause candidate: name the cause and verification status.</a:t>
+            </a:r>
+          </a:p>
+          <a:p>
+            <a:pPr>
+              <a:defRPr sz="1100">
+                <a:solidFill>
+                  <a:srgbClr val="2D3741"/>
+                </a:solidFill>
+              </a:defRPr>
+            </a:pPr>
+            <a:r>
+              <a:t>Next action: verify the link or design a countermeasure.</a:t>
+            </a:r>
+          </a:p>
+          <a:p>
+            <a:pPr>
+              <a:defRPr sz="1100">
+                <a:solidFill>
+                  <a:srgbClr val="2D3741"/>
+                </a:solidFill>
+              </a:defRPr>
+            </a:pPr>
+            <a:r>
+              <a:t>Caution: the worksheet does not prove root cause by count of whys.</a:t>
+            </a:r>
+          </a:p>
+        </p:txBody>
+      </p:sp>
+      <p:sp>
+        <p:nvSpPr>
+          <p:cNvPr id="6" name="Rounded Rectangle 5"/>
+          <p:cNvSpPr/>
+          <p:nvPr/>
+        </p:nvSpPr>
+        <p:spPr>
+          <a:xfrm>
+            <a:off x="6263640" y="1325880"/>
+            <a:ext cx="5212080" cy="4526280"/>
+          </a:xfrm>
+          <a:prstGeom prst="roundRect">
+            <a:avLst/>
+          </a:prstGeom>
+          <a:solidFill>
+            <a:srgbClr val="F8F9F7"/>
+          </a:solidFill>
+          <a:ln>
+            <a:solidFill>
+              <a:srgbClr val="BEC4BF"/>
+            </a:solidFill>
+          </a:ln>
+        </p:spPr>
+        <p:style>
+          <a:lnRef idx="1">
+            <a:schemeClr val="accent1"/>
+          </a:lnRef>
+          <a:fillRef idx="3">
+            <a:schemeClr val="accent1"/>
+          </a:fillRef>
+          <a:effectRef idx="2">
+            <a:schemeClr val="accent1"/>
+          </a:effectRef>
+          <a:fontRef idx="minor">
+            <a:schemeClr val="lt1"/>
+          </a:fontRef>
+        </p:style>
+        <p:txBody>
+          <a:bodyPr rtlCol="0" anchor="t" lIns="164592" rIns="164592" tIns="128016"/>
+          <a:lstStyle/>
+          <a:p>
+            <a:pPr algn="ctr"/>
+            <a:r>
+              <a:rPr b="1" sz="1500">
+                <a:solidFill>
+                  <a:srgbClr val="1B2733"/>
+                </a:solidFill>
+              </a:rPr>
+              <a:t>Common mistakes</a:t>
+            </a:r>
+          </a:p>
+          <a:p>
+            <a:pPr>
+              <a:defRPr sz="1100">
+                <a:solidFill>
+                  <a:srgbClr val="2D3741"/>
+                </a:solidFill>
+              </a:defRPr>
+            </a:pPr>
+            <a:r>
+              <a:t>Branching into multiple problems.</a:t>
+            </a:r>
+          </a:p>
+          <a:p>
+            <a:pPr>
+              <a:defRPr sz="1100">
+                <a:solidFill>
+                  <a:srgbClr val="2D3741"/>
+                </a:solidFill>
+              </a:defRPr>
+            </a:pPr>
+            <a:r>
+              <a:t>Skipping evidence checks.</a:t>
+            </a:r>
+          </a:p>
+          <a:p>
+            <a:pPr>
+              <a:defRPr sz="1100">
+                <a:solidFill>
+                  <a:srgbClr val="2D3741"/>
+                </a:solidFill>
+              </a:defRPr>
+            </a:pPr>
+            <a:r>
+              <a:t>Stopping at a convenient answer.</a:t>
+            </a:r>
+          </a:p>
+          <a:p>
+            <a:pPr>
+              <a:defRPr sz="1100">
+                <a:solidFill>
+                  <a:srgbClr val="2D3741"/>
+                </a:solidFill>
+              </a:defRPr>
+            </a:pPr>
+            <a:r>
+              <a:t>Treating demo content as project evidence.</a:t>
+            </a:r>
+          </a:p>
+        </p:txBody>
+      </p:sp>
+      <p:sp>
+        <p:nvSpPr>
+          <p:cNvPr id="7" name="TextBox 6"/>
+          <p:cNvSpPr txBox="1"/>
+          <p:nvPr/>
+        </p:nvSpPr>
+        <p:spPr>
+          <a:xfrm>
+            <a:off x="548640" y="6355080"/>
+            <a:ext cx="10881360" cy="228600"/>
+          </a:xfrm>
+          <a:prstGeom prst="rect">
+            <a:avLst/>
+          </a:prstGeom>
+          <a:noFill/>
+        </p:spPr>
+        <p:txBody>
+          <a:bodyPr wrap="square" lIns="73152" rIns="73152">
+            <a:spAutoFit/>
+          </a:bodyPr>
+          <a:lstStyle/>
+          <a:p>
+            <a:r>
+              <a:rPr sz="800" b="0">
+                <a:solidFill>
+                  <a:srgbClr val="697077"/>
+                </a:solidFill>
+              </a:rPr>
+              <a:t>5_whys_method_template | 5_whys | Final data-dependent evidence belongs in the evidence package.</a:t>
+            </a:r>
+          </a:p>
+        </p:txBody>
+      </p:sp>
+    </p:spTree>
+  </p:cSld>
+  <p:clrMapOvr>
+    <a:masterClrMapping/>
+  </p:clrMapOvr>
+</p:sld>
+</file>
+
+<file path=ppt/slides/slide7.xml><?xml version="1.0" encoding="utf-8"?>
+<p:sld xmlns:a="http://schemas.openxmlformats.org/drawingml/2006/main" xmlns:p="http://schemas.openxmlformats.org/presentationml/2006/main" xmlns:r="http://schemas.openxmlformats.org/officeDocument/2006/relationships">
+  <p:cSld>
+    <p:spTree>
+      <p:nvGrpSpPr>
+        <p:cNvPr id="1" name=""/>
+        <p:cNvGrpSpPr/>
+        <p:nvPr/>
+      </p:nvGrpSpPr>
+      <p:grpSpPr/>
+      <p:sp>
+        <p:nvSpPr>
+          <p:cNvPr id="2" name="TextBox 1"/>
+          <p:cNvSpPr txBox="1"/>
+          <p:nvPr/>
+        </p:nvSpPr>
+        <p:spPr>
+          <a:xfrm>
+            <a:off x="502920" y="256032"/>
+            <a:ext cx="8321040" cy="420624"/>
+          </a:xfrm>
+          <a:prstGeom prst="rect">
+            <a:avLst/>
+          </a:prstGeom>
+          <a:noFill/>
+        </p:spPr>
+        <p:txBody>
+          <a:bodyPr wrap="square" lIns="73152" rIns="73152">
+            <a:spAutoFit/>
+          </a:bodyPr>
+          <a:lstStyle/>
+          <a:p>
+            <a:r>
+              <a:rPr sz="2400" b="1">
+                <a:solidFill>
+                  <a:srgbClr val="1B2733"/>
+                </a:solidFill>
+              </a:rPr>
+              <a:t>Facilitator checklist and Python assist decision</a:t>
+            </a:r>
+          </a:p>
+        </p:txBody>
+      </p:sp>
+      <p:sp>
+        <p:nvSpPr>
+          <p:cNvPr id="3" name="TextBox 2"/>
+          <p:cNvSpPr txBox="1"/>
+          <p:nvPr/>
+        </p:nvSpPr>
+        <p:spPr>
+          <a:xfrm>
+            <a:off x="521207" y="713232"/>
+            <a:ext cx="7772400" cy="237744"/>
+          </a:xfrm>
+          <a:prstGeom prst="rect">
+            <a:avLst/>
+          </a:prstGeom>
+          <a:noFill/>
+        </p:spPr>
+        <p:txBody>
+          <a:bodyPr wrap="square" lIns="73152" rIns="73152">
+            <a:spAutoFit/>
+          </a:bodyPr>
+          <a:lstStyle/>
+          <a:p>
+            <a:r>
+              <a:rPr sz="1100" b="0">
+                <a:solidFill>
+                  <a:srgbClr val="5A636C"/>
+                </a:solidFill>
+              </a:rPr>
+              <a:t>5 Whys</a:t>
+            </a:r>
+          </a:p>
+        </p:txBody>
+      </p:sp>
+      <p:sp>
+        <p:nvSpPr>
+          <p:cNvPr id="4" name="Rectangle 3"/>
+          <p:cNvSpPr/>
+          <p:nvPr/>
+        </p:nvSpPr>
+        <p:spPr>
+          <a:xfrm>
+            <a:off x="502920" y="941832"/>
+            <a:ext cx="11155680" cy="27432"/>
+          </a:xfrm>
+          <a:prstGeom prst="rect">
+            <a:avLst/>
+          </a:prstGeom>
+          <a:solidFill>
+            <a:srgbClr val="427E78"/>
+          </a:solidFill>
+          <a:ln>
+            <a:noFill/>
+          </a:ln>
+        </p:spPr>
+        <p:style>
+          <a:lnRef idx="1">
+            <a:schemeClr val="accent1"/>
+          </a:lnRef>
+          <a:fillRef idx="3">
+            <a:schemeClr val="accent1"/>
+          </a:fillRef>
+          <a:effectRef idx="2">
+            <a:schemeClr val="accent1"/>
+          </a:effectRef>
+          <a:fontRef idx="minor">
+            <a:schemeClr val="lt1"/>
+          </a:fontRef>
+        </p:style>
+        <p:txBody>
+          <a:bodyPr rtlCol="0" anchor="ctr"/>
+          <a:lstStyle/>
+          <a:p>
+            <a:pPr algn="ctr"/>
+          </a:p>
+        </p:txBody>
+      </p:sp>
+      <p:sp>
+        <p:nvSpPr>
+          <p:cNvPr id="5" name="Rounded Rectangle 4"/>
+          <p:cNvSpPr/>
+          <p:nvPr/>
+        </p:nvSpPr>
+        <p:spPr>
+          <a:xfrm>
+            <a:off x="640080" y="1325880"/>
+            <a:ext cx="5212080" cy="4526280"/>
+          </a:xfrm>
+          <a:prstGeom prst="roundRect">
+            <a:avLst/>
+          </a:prstGeom>
+          <a:solidFill>
+            <a:srgbClr val="F8F9F7"/>
+          </a:solidFill>
+          <a:ln>
+            <a:solidFill>
+              <a:srgbClr val="BEC4BF"/>
+            </a:solidFill>
+          </a:ln>
+        </p:spPr>
+        <p:style>
+          <a:lnRef idx="1">
+            <a:schemeClr val="accent1"/>
+          </a:lnRef>
+          <a:fillRef idx="3">
+            <a:schemeClr val="accent1"/>
+          </a:fillRef>
+          <a:effectRef idx="2">
+            <a:schemeClr val="accent1"/>
+          </a:effectRef>
+          <a:fontRef idx="minor">
+            <a:schemeClr val="lt1"/>
+          </a:fontRef>
+        </p:style>
+        <p:txBody>
+          <a:bodyPr rtlCol="0" anchor="t" lIns="164592" rIns="164592" tIns="128016"/>
+          <a:lstStyle/>
+          <a:p>
+            <a:pPr algn="ctr"/>
+            <a:r>
+              <a:rPr b="1" sz="1500">
+                <a:solidFill>
+                  <a:srgbClr val="1B2733"/>
+                </a:solidFill>
+              </a:rPr>
+              <a:t>Facilitator checklist</a:t>
+            </a:r>
+          </a:p>
+          <a:p>
+            <a:pPr>
+              <a:defRPr sz="1100">
+                <a:solidFill>
+                  <a:srgbClr val="2D3741"/>
+                </a:solidFill>
+              </a:defRPr>
+            </a:pPr>
+            <a:r>
+              <a:t>Starting problem is narrow.</a:t>
+            </a:r>
+          </a:p>
+          <a:p>
+            <a:pPr>
+              <a:defRPr sz="1100">
+                <a:solidFill>
+                  <a:srgbClr val="2D3741"/>
+                </a:solidFill>
+              </a:defRPr>
+            </a:pPr>
+            <a:r>
+              <a:t>Source and date range shown for evidence checks.</a:t>
+            </a:r>
+          </a:p>
+          <a:p>
+            <a:pPr>
+              <a:defRPr sz="1100">
+                <a:solidFill>
+                  <a:srgbClr val="2D3741"/>
+                </a:solidFill>
+              </a:defRPr>
+            </a:pPr>
+            <a:r>
+              <a:t>Each why follows from the previous answer.</a:t>
+            </a:r>
+          </a:p>
+          <a:p>
+            <a:pPr>
+              <a:defRPr sz="1100">
+                <a:solidFill>
+                  <a:srgbClr val="2D3741"/>
+                </a:solidFill>
+              </a:defRPr>
+            </a:pPr>
+            <a:r>
+              <a:t>Key conclusion and next action are written.</a:t>
+            </a:r>
+          </a:p>
+        </p:txBody>
+      </p:sp>
+      <p:sp>
+        <p:nvSpPr>
+          <p:cNvPr id="6" name="Rounded Rectangle 5"/>
+          <p:cNvSpPr/>
+          <p:nvPr/>
+        </p:nvSpPr>
+        <p:spPr>
+          <a:xfrm>
+            <a:off x="6263640" y="1325880"/>
+            <a:ext cx="5212080" cy="4526280"/>
+          </a:xfrm>
+          <a:prstGeom prst="roundRect">
+            <a:avLst/>
+          </a:prstGeom>
+          <a:solidFill>
+            <a:srgbClr val="F8F9F7"/>
+          </a:solidFill>
+          <a:ln>
+            <a:solidFill>
+              <a:srgbClr val="BEC4BF"/>
+            </a:solidFill>
+          </a:ln>
+        </p:spPr>
+        <p:style>
+          <a:lnRef idx="1">
+            <a:schemeClr val="accent1"/>
+          </a:lnRef>
+          <a:fillRef idx="3">
+            <a:schemeClr val="accent1"/>
+          </a:fillRef>
+          <a:effectRef idx="2">
+            <a:schemeClr val="accent1"/>
+          </a:effectRef>
+          <a:fontRef idx="minor">
+            <a:schemeClr val="lt1"/>
+          </a:fontRef>
+        </p:style>
+        <p:txBody>
+          <a:bodyPr rtlCol="0" anchor="t" lIns="164592" rIns="164592" tIns="128016"/>
+          <a:lstStyle/>
+          <a:p>
+            <a:pPr algn="ctr"/>
+            <a:r>
+              <a:rPr b="1" sz="1500">
+                <a:solidFill>
+                  <a:srgbClr val="1B2733"/>
+                </a:solidFill>
+              </a:rPr>
+              <a:t>Python assist decision</a:t>
+            </a:r>
+          </a:p>
+          <a:p>
+            <a:pPr>
+              <a:defRPr sz="1100">
+                <a:solidFill>
+                  <a:srgbClr val="2D3741"/>
+                </a:solidFill>
+              </a:defRPr>
+            </a:pPr>
+            <a:r>
+              <a:t>PowerPoint is enough for teaching, draft, and normal 5 Whys use.</a:t>
+            </a:r>
+          </a:p>
+          <a:p>
+            <a:pPr>
+              <a:defRPr sz="1100">
+                <a:solidFill>
+                  <a:srgbClr val="2D3741"/>
+                </a:solidFill>
+              </a:defRPr>
+            </a:pPr>
+            <a:r>
+              <a:t>Python is not normally needed for this reasoning worksheet.</a:t>
+            </a:r>
+          </a:p>
+          <a:p>
+            <a:pPr>
+              <a:defRPr sz="1100">
+                <a:solidFill>
+                  <a:srgbClr val="2D3741"/>
+                </a:solidFill>
+              </a:defRPr>
+            </a:pPr>
+            <a:r>
+              <a:t>Use Python later only to summarize verification data.</a:t>
+            </a:r>
+          </a:p>
+          <a:p>
+            <a:pPr>
+              <a:defRPr sz="1100">
+                <a:solidFill>
+                  <a:srgbClr val="2D3741"/>
+                </a:solidFill>
+              </a:defRPr>
+            </a:pPr>
+            <a:r>
+              <a:t>High-rigor data claims need a validated path.</a:t>
+            </a:r>
+          </a:p>
+        </p:txBody>
+      </p:sp>
+      <p:sp>
+        <p:nvSpPr>
+          <p:cNvPr id="7" name="TextBox 6"/>
+          <p:cNvSpPr txBox="1"/>
+          <p:nvPr/>
+        </p:nvSpPr>
+        <p:spPr>
+          <a:xfrm>
+            <a:off x="548640" y="6355080"/>
+            <a:ext cx="10881360" cy="228600"/>
+          </a:xfrm>
+          <a:prstGeom prst="rect">
+            <a:avLst/>
+          </a:prstGeom>
+          <a:noFill/>
+        </p:spPr>
+        <p:txBody>
+          <a:bodyPr wrap="square" lIns="73152" rIns="73152">
+            <a:spAutoFit/>
+          </a:bodyPr>
+          <a:lstStyle/>
+          <a:p>
+            <a:r>
+              <a:rPr sz="800" b="0">
+                <a:solidFill>
+                  <a:srgbClr val="697077"/>
+                </a:solidFill>
+              </a:rPr>
+              <a:t>5_whys_method_template | 5_whys | Final data-dependent evidence belongs in the evidence package.</a:t>
+            </a:r>
+          </a:p>
+        </p:txBody>
+      </p:sp>
+    </p:spTree>
+  </p:cSld>
+  <p:clrMapOvr>
+    <a:masterClrMapping/>
+  </p:clrMapOvr>
+</p:sld>
+</file>
+
+<file path=ppt/slides/slide8.xml><?xml version="1.0" encoding="utf-8"?>
+<p:sld xmlns:a="http://schemas.openxmlformats.org/drawingml/2006/main" xmlns:p="http://schemas.openxmlformats.org/presentationml/2006/main" xmlns:r="http://schemas.openxmlformats.org/officeDocument/2006/relationships">
+  <p:cSld>
+    <p:spTree>
+      <p:nvGrpSpPr>
+        <p:cNvPr id="1" name=""/>
+        <p:cNvGrpSpPr/>
+        <p:nvPr/>
+      </p:nvGrpSpPr>
+      <p:grpSpPr/>
+      <p:sp>
+        <p:nvSpPr>
+          <p:cNvPr id="2" name="TextBox 1"/>
+          <p:cNvSpPr txBox="1"/>
+          <p:nvPr/>
+        </p:nvSpPr>
+        <p:spPr>
+          <a:xfrm>
+            <a:off x="502920" y="256032"/>
+            <a:ext cx="8321040" cy="420624"/>
+          </a:xfrm>
+          <a:prstGeom prst="rect">
+            <a:avLst/>
+          </a:prstGeom>
+          <a:noFill/>
+        </p:spPr>
+        <p:txBody>
+          <a:bodyPr wrap="square" lIns="73152" rIns="73152">
+            <a:spAutoFit/>
+          </a:bodyPr>
+          <a:lstStyle/>
+          <a:p>
+            <a:r>
+              <a:rPr sz="2400" b="1">
+                <a:solidFill>
+                  <a:srgbClr val="1B2733"/>
+                </a:solidFill>
+              </a:rPr>
+              <a:t>Evidence/source note</a:t>
+            </a:r>
+          </a:p>
+        </p:txBody>
+      </p:sp>
+      <p:sp>
+        <p:nvSpPr>
+          <p:cNvPr id="3" name="TextBox 2"/>
+          <p:cNvSpPr txBox="1"/>
+          <p:nvPr/>
+        </p:nvSpPr>
+        <p:spPr>
+          <a:xfrm>
+            <a:off x="521207" y="713232"/>
+            <a:ext cx="7772400" cy="237744"/>
+          </a:xfrm>
+          <a:prstGeom prst="rect">
+            <a:avLst/>
+          </a:prstGeom>
+          <a:noFill/>
+        </p:spPr>
+        <p:txBody>
+          <a:bodyPr wrap="square" lIns="73152" rIns="73152">
+            <a:spAutoFit/>
+          </a:bodyPr>
+          <a:lstStyle/>
+          <a:p>
+            <a:r>
+              <a:rPr sz="1100" b="0">
+                <a:solidFill>
+                  <a:srgbClr val="5A636C"/>
+                </a:solidFill>
+              </a:rPr>
+              <a:t>5 Whys</a:t>
+            </a:r>
+          </a:p>
+        </p:txBody>
+      </p:sp>
+      <p:sp>
+        <p:nvSpPr>
+          <p:cNvPr id="4" name="Rectangle 3"/>
+          <p:cNvSpPr/>
+          <p:nvPr/>
+        </p:nvSpPr>
+        <p:spPr>
+          <a:xfrm>
+            <a:off x="502920" y="941832"/>
+            <a:ext cx="11155680" cy="27432"/>
+          </a:xfrm>
+          <a:prstGeom prst="rect">
+            <a:avLst/>
+          </a:prstGeom>
+          <a:solidFill>
+            <a:srgbClr val="427E78"/>
+          </a:solidFill>
+          <a:ln>
+            <a:noFill/>
+          </a:ln>
+        </p:spPr>
+        <p:style>
+          <a:lnRef idx="1">
+            <a:schemeClr val="accent1"/>
+          </a:lnRef>
+          <a:fillRef idx="3">
+            <a:schemeClr val="accent1"/>
+          </a:fillRef>
+          <a:effectRef idx="2">
+            <a:schemeClr val="accent1"/>
+          </a:effectRef>
+          <a:fontRef idx="minor">
+            <a:schemeClr val="lt1"/>
+          </a:fontRef>
+        </p:style>
+        <p:txBody>
+          <a:bodyPr rtlCol="0" anchor="ctr"/>
+          <a:lstStyle/>
+          <a:p>
+            <a:pPr algn="ctr"/>
+          </a:p>
+        </p:txBody>
+      </p:sp>
+      <p:sp>
+        <p:nvSpPr>
+          <p:cNvPr id="5" name="Rounded Rectangle 4"/>
+          <p:cNvSpPr/>
+          <p:nvPr/>
+        </p:nvSpPr>
+        <p:spPr>
+          <a:xfrm>
+            <a:off x="640080" y="1325880"/>
+            <a:ext cx="5212080" cy="4526280"/>
+          </a:xfrm>
+          <a:prstGeom prst="roundRect">
+            <a:avLst/>
+          </a:prstGeom>
+          <a:solidFill>
+            <a:srgbClr val="F8F9F7"/>
+          </a:solidFill>
+          <a:ln>
+            <a:solidFill>
+              <a:srgbClr val="BEC4BF"/>
+            </a:solidFill>
+          </a:ln>
+        </p:spPr>
+        <p:style>
+          <a:lnRef idx="1">
+            <a:schemeClr val="accent1"/>
+          </a:lnRef>
+          <a:fillRef idx="3">
+            <a:schemeClr val="accent1"/>
+          </a:fillRef>
+          <a:effectRef idx="2">
+            <a:schemeClr val="accent1"/>
+          </a:effectRef>
+          <a:fontRef idx="minor">
+            <a:schemeClr val="lt1"/>
+          </a:fontRef>
+        </p:style>
+        <p:txBody>
+          <a:bodyPr rtlCol="0" anchor="t" lIns="164592" rIns="164592" tIns="128016"/>
+          <a:lstStyle/>
+          <a:p>
+            <a:pPr algn="ctr"/>
+            <a:r>
+              <a:rPr b="1" sz="1500">
+                <a:solidFill>
+                  <a:srgbClr val="1B2733"/>
+                </a:solidFill>
+              </a:rPr>
+              <a:t>Evidence levels</a:t>
+            </a:r>
+          </a:p>
+          <a:p>
+            <a:pPr>
+              <a:defRPr sz="1100">
+                <a:solidFill>
+                  <a:srgbClr val="2D3741"/>
+                </a:solidFill>
+              </a:defRPr>
+            </a:pPr>
+            <a:r>
+              <a:t>Level 1: teaching/draft PowerPoint edits.</a:t>
+            </a:r>
+          </a:p>
+          <a:p>
+            <a:pPr>
+              <a:defRPr sz="1100">
+                <a:solidFill>
+                  <a:srgbClr val="2D3741"/>
+                </a:solidFill>
+              </a:defRPr>
+            </a:pPr>
+            <a:r>
+              <a:t>Level 2: normal project with source and checklist evidence.</a:t>
+            </a:r>
+          </a:p>
+          <a:p>
+            <a:pPr>
+              <a:defRPr sz="1100">
+                <a:solidFill>
+                  <a:srgbClr val="2D3741"/>
+                </a:solidFill>
+              </a:defRPr>
+            </a:pPr>
+            <a:r>
+              <a:t>Level 3: formal review with source data and versioned template.</a:t>
+            </a:r>
+          </a:p>
+          <a:p>
+            <a:pPr>
+              <a:defRPr sz="1100">
+                <a:solidFill>
+                  <a:srgbClr val="2D3741"/>
+                </a:solidFill>
+              </a:defRPr>
+            </a:pPr>
+            <a:r>
+              <a:t>Level 4: audit/high-risk reproducible evidence.</a:t>
+            </a:r>
+          </a:p>
+        </p:txBody>
+      </p:sp>
+      <p:sp>
+        <p:nvSpPr>
+          <p:cNvPr id="6" name="Rounded Rectangle 5"/>
+          <p:cNvSpPr/>
+          <p:nvPr/>
+        </p:nvSpPr>
+        <p:spPr>
+          <a:xfrm>
+            <a:off x="6263640" y="1325880"/>
+            <a:ext cx="5212080" cy="4526280"/>
+          </a:xfrm>
+          <a:prstGeom prst="roundRect">
+            <a:avLst/>
+          </a:prstGeom>
+          <a:solidFill>
+            <a:srgbClr val="F8F9F7"/>
+          </a:solidFill>
+          <a:ln>
+            <a:solidFill>
+              <a:srgbClr val="BEC4BF"/>
+            </a:solidFill>
+          </a:ln>
+        </p:spPr>
+        <p:style>
+          <a:lnRef idx="1">
+            <a:schemeClr val="accent1"/>
+          </a:lnRef>
+          <a:fillRef idx="3">
+            <a:schemeClr val="accent1"/>
+          </a:fillRef>
+          <a:effectRef idx="2">
+            <a:schemeClr val="accent1"/>
+          </a:effectRef>
+          <a:fontRef idx="minor">
+            <a:schemeClr val="lt1"/>
+          </a:fontRef>
+        </p:style>
+        <p:txBody>
+          <a:bodyPr rtlCol="0" anchor="t" lIns="164592" rIns="164592" tIns="128016"/>
+          <a:lstStyle/>
+          <a:p>
+            <a:pPr algn="ctr"/>
+            <a:r>
+              <a:rPr b="1" sz="1500">
+                <a:solidFill>
+                  <a:srgbClr val="1B2733"/>
+                </a:solidFill>
+              </a:rPr>
+              <a:t>Evidence/source note</a:t>
+            </a:r>
+          </a:p>
+          <a:p>
+            <a:pPr>
+              <a:defRPr sz="1100">
+                <a:solidFill>
+                  <a:srgbClr val="2D3741"/>
+                </a:solidFill>
+              </a:defRPr>
+            </a:pPr>
+            <a:r>
+              <a:t>Record source.</a:t>
+            </a:r>
+          </a:p>
+          <a:p>
+            <a:pPr>
+              <a:defRPr sz="1100">
+                <a:solidFill>
+                  <a:srgbClr val="2D3741"/>
+                </a:solidFill>
+              </a:defRPr>
+            </a:pPr>
+            <a:r>
+              <a:t>Record date range.</a:t>
+            </a:r>
+          </a:p>
+          <a:p>
+            <a:pPr>
+              <a:defRPr sz="1100">
+                <a:solidFill>
+                  <a:srgbClr val="2D3741"/>
+                </a:solidFill>
+              </a:defRPr>
+            </a:pPr>
+            <a:r>
+              <a:t>Record evidence checks and assumptions.</a:t>
+            </a:r>
+          </a:p>
+          <a:p>
+            <a:pPr>
+              <a:defRPr sz="1100">
+                <a:solidFill>
+                  <a:srgbClr val="2D3741"/>
+                </a:solidFill>
+              </a:defRPr>
+            </a:pPr>
+            <a:r>
+              <a:t>Record prepared by/date.</a:t>
+            </a:r>
+          </a:p>
+        </p:txBody>
+      </p:sp>
+      <p:sp>
+        <p:nvSpPr>
+          <p:cNvPr id="7" name="TextBox 6"/>
+          <p:cNvSpPr txBox="1"/>
+          <p:nvPr/>
+        </p:nvSpPr>
+        <p:spPr>
+          <a:xfrm>
+            <a:off x="548640" y="6355080"/>
+            <a:ext cx="10881360" cy="228600"/>
+          </a:xfrm>
+          <a:prstGeom prst="rect">
+            <a:avLst/>
+          </a:prstGeom>
+          <a:noFill/>
+        </p:spPr>
+        <p:txBody>
+          <a:bodyPr wrap="square" lIns="73152" rIns="73152">
+            <a:spAutoFit/>
+          </a:bodyPr>
+          <a:lstStyle/>
+          <a:p>
+            <a:r>
+              <a:rPr sz="800" b="0">
+                <a:solidFill>
+                  <a:srgbClr val="697077"/>
+                </a:solidFill>
+              </a:rPr>
+              <a:t>5_whys_method_template | 5_whys | Final data-dependent evidence belongs in the evidence package.</a:t>
+            </a:r>
+          </a:p>
+        </p:txBody>
+      </p:sp>
+    </p:spTree>
+  </p:cSld>
+  <p:clrMapOvr>
+    <a:masterClrMapping/>
+  </p:clrMapOvr>
+</p:sld>
+</file>
+
+<file path=ppt/slides/slide9.xml><?xml version="1.0" encoding="utf-8"?>
+<p:sld xmlns:a="http://schemas.openxmlformats.org/drawingml/2006/main" xmlns:p="http://schemas.openxmlformats.org/presentationml/2006/main" xmlns:r="http://schemas.openxmlformats.org/officeDocument/2006/relationships">
+  <p:cSld>
+    <p:spTree>
+      <p:nvGrpSpPr>
+        <p:cNvPr id="1" name=""/>
+        <p:cNvGrpSpPr/>
+        <p:nvPr/>
+      </p:nvGrpSpPr>
+      <p:grpSpPr/>
+      <p:sp>
+        <p:nvSpPr>
+          <p:cNvPr id="2" name="TextBox 1"/>
+          <p:cNvSpPr txBox="1"/>
+          <p:nvPr/>
+        </p:nvSpPr>
+        <p:spPr>
+          <a:xfrm>
+            <a:off x="502920" y="256032"/>
+            <a:ext cx="8321040" cy="420624"/>
+          </a:xfrm>
+          <a:prstGeom prst="rect">
+            <a:avLst/>
+          </a:prstGeom>
+          <a:noFill/>
+        </p:spPr>
+        <p:txBody>
+          <a:bodyPr wrap="square" lIns="73152" rIns="73152">
+            <a:spAutoFit/>
+          </a:bodyPr>
+          <a:lstStyle/>
+          <a:p>
+            <a:r>
+              <a:rPr sz="2400" b="1">
+                <a:solidFill>
+                  <a:srgbClr val="1B2733"/>
+                </a:solidFill>
+              </a:rPr>
+              <a:t>DEMO EXAMPLE - not project evidence</a:t>
+            </a:r>
+          </a:p>
+        </p:txBody>
+      </p:sp>
+      <p:sp>
+        <p:nvSpPr>
+          <p:cNvPr id="3" name="TextBox 2"/>
+          <p:cNvSpPr txBox="1"/>
+          <p:nvPr/>
+        </p:nvSpPr>
+        <p:spPr>
+          <a:xfrm>
+            <a:off x="521207" y="713232"/>
+            <a:ext cx="7772400" cy="237744"/>
+          </a:xfrm>
+          <a:prstGeom prst="rect">
+            <a:avLst/>
+          </a:prstGeom>
+          <a:noFill/>
+        </p:spPr>
+        <p:txBody>
+          <a:bodyPr wrap="square" lIns="73152" rIns="73152">
+            <a:spAutoFit/>
+          </a:bodyPr>
+          <a:lstStyle/>
+          <a:p>
+            <a:r>
+              <a:rPr sz="1100" b="0">
+                <a:solidFill>
+                  <a:srgbClr val="5A636C"/>
+                </a:solidFill>
+              </a:rPr>
+              <a:t>5 Whys</a:t>
+            </a:r>
+          </a:p>
+        </p:txBody>
+      </p:sp>
+      <p:sp>
+        <p:nvSpPr>
+          <p:cNvPr id="4" name="Rectangle 3"/>
+          <p:cNvSpPr/>
+          <p:nvPr/>
+        </p:nvSpPr>
+        <p:spPr>
+          <a:xfrm>
+            <a:off x="502920" y="941832"/>
+            <a:ext cx="11155680" cy="27432"/>
+          </a:xfrm>
+          <a:prstGeom prst="rect">
+            <a:avLst/>
+          </a:prstGeom>
+          <a:solidFill>
+            <a:srgbClr val="427E78"/>
+          </a:solidFill>
+          <a:ln>
+            <a:noFill/>
+          </a:ln>
+        </p:spPr>
+        <p:style>
+          <a:lnRef idx="1">
+            <a:schemeClr val="accent1"/>
+          </a:lnRef>
+          <a:fillRef idx="3">
+            <a:schemeClr val="accent1"/>
+          </a:fillRef>
+          <a:effectRef idx="2">
+            <a:schemeClr val="accent1"/>
+          </a:effectRef>
+          <a:fontRef idx="minor">
+            <a:schemeClr val="lt1"/>
+          </a:fontRef>
+        </p:style>
+        <p:txBody>
+          <a:bodyPr rtlCol="0" anchor="ctr"/>
+          <a:lstStyle/>
+          <a:p>
+            <a:pPr algn="ctr"/>
+          </a:p>
+        </p:txBody>
+      </p:sp>
+      <p:sp>
+        <p:nvSpPr>
+          <p:cNvPr id="5" name="Rounded Rectangle 4"/>
+          <p:cNvSpPr/>
+          <p:nvPr/>
+        </p:nvSpPr>
+        <p:spPr>
+          <a:xfrm>
             <a:off x="640080" y="1051560"/>
-            <a:ext cx="4754880" cy="329184"/>
+            <a:ext cx="3840480" cy="329184"/>
           </a:xfrm>
           <a:prstGeom prst="roundRect">
             <a:avLst/>
@@ -5023,7 +7189,7 @@
                   <a:srgbClr val="664B11"/>
                 </a:solidFill>
               </a:rPr>
-              <a:t>Replace demo content with project evidence</a:t>
+              <a:t>DEMO EXAMPLE - not project evidence</a:t>
             </a:r>
           </a:p>
         </p:txBody>
@@ -5076,43 +7242,67 @@
                   <a:srgbClr val="1B2733"/>
                 </a:solidFill>
               </a:rPr>
-              <a:t>Project slide checklist</a:t>
-            </a:r>
-          </a:p>
-          <a:p>
-            <a:pPr>
-              <a:defRPr sz="1100">
-                <a:solidFill>
-                  <a:srgbClr val="2D3741"/>
-                </a:solidFill>
-              </a:defRPr>
-            </a:pPr>
-            <a:r>
-              <a:t>Replace the rows with project why answers.</a:t>
-            </a:r>
-          </a:p>
-          <a:p>
-            <a:pPr>
-              <a:defRPr sz="1100">
-                <a:solidFill>
-                  <a:srgbClr val="2D3741"/>
-                </a:solidFill>
-              </a:defRPr>
-            </a:pPr>
-            <a:r>
-              <a:t>State the candidate root cause in {{root_cause}}.</a:t>
-            </a:r>
-          </a:p>
-          <a:p>
-            <a:pPr>
-              <a:defRPr sz="1100">
-                <a:solidFill>
-                  <a:srgbClr val="2D3741"/>
-                </a:solidFill>
-              </a:defRPr>
-            </a:pPr>
-            <a:r>
-              <a:t>Record evidence status in {{verification}}.</a:t>
+              <a:t>Demo structure</a:t>
+            </a:r>
+          </a:p>
+          <a:p>
+            <a:pPr>
+              <a:defRPr sz="1100">
+                <a:solidFill>
+                  <a:srgbClr val="2D3741"/>
+                </a:solidFill>
+              </a:defRPr>
+            </a:pPr>
+            <a:r>
+              <a:t>Change data only: replace the why-chain answers and evidence checks.</a:t>
+            </a:r>
+          </a:p>
+          <a:p>
+            <a:pPr>
+              <a:defRPr sz="1100">
+                <a:solidFill>
+                  <a:srgbClr val="2D3741"/>
+                </a:solidFill>
+              </a:defRPr>
+            </a:pPr>
+            <a:r>
+              <a:t>Problem: {{problem}}</a:t>
+            </a:r>
+          </a:p>
+          <a:p>
+            <a:pPr>
+              <a:defRPr sz="1100">
+                <a:solidFill>
+                  <a:srgbClr val="2D3741"/>
+                </a:solidFill>
+              </a:defRPr>
+            </a:pPr>
+            <a:r>
+              <a:t>Why chain: {{why_chain}}</a:t>
+            </a:r>
+          </a:p>
+          <a:p>
+            <a:pPr>
+              <a:defRPr sz="1100">
+                <a:solidFill>
+                  <a:srgbClr val="2D3741"/>
+                </a:solidFill>
+              </a:defRPr>
+            </a:pPr>
+            <a:r>
+              <a:t>Root cause: {{root_cause}}</a:t>
+            </a:r>
+          </a:p>
+          <a:p>
+            <a:pPr>
+              <a:defRPr sz="1100">
+                <a:solidFill>
+                  <a:srgbClr val="2D3741"/>
+                </a:solidFill>
+              </a:defRPr>
+            </a:pPr>
+            <a:r>
+              <a:t>Verification: {{verification}}</a:t>
             </a:r>
           </a:p>
         </p:txBody>

</xml_diff>